<commit_message>
Add slide with example post images to briefing deck
Co-Authored-By: Claude Opus 5.5 <noreply@anthropic.com>
Claude-Session: https://claude.ai/code/session_017H2nDFJncHL4WTwSKmVUUD
</commit_message>
<xml_diff>
--- a/ici_analysis/KBRI_Wina_Penataan_Konten_Instagram.pptx
+++ b/ici_analysis/KBRI_Wina_Penataan_Konten_Instagram.pptx
@@ -16,9 +16,10 @@
     <p:sldId id="264" r:id="rId10"/>
     <p:sldId id="265" r:id="rId11"/>
     <p:sldId id="266" r:id="rId12"/>
+    <p:sldId id="267" r:id="rId13"/>
   </p:sldIdLst>
   <p:notesMasterIdLst>
-    <p:notesMasterId r:id="rId13"/>
+    <p:notesMasterId r:id="rId14"/>
   </p:notesMasterIdLst>
   <p:sldSz cx="12192000" cy="6858000"/>
   <p:notesSz cx="6858000" cy="12192000"/>
@@ -978,6 +979,94 @@
             <a:fld id="{F7021451-1387-4CA6-816F-3879F97B5CBC}" type="slidenum">
               <a:rPr lang="en-US"/>
               <a:t>11</a:t>
+            </a:fld>
+            <a:endParaRPr lang="en-US"/>
+          </a:p>
+        </p:txBody>
+      </p:sp>
+    </p:spTree>
+    <p:extLst>
+      <p:ext uri="{BB962C8B-B14F-4D97-AF65-F5344CB8AC3E}">
+        <p14:creationId xmlns:p14="http://schemas.microsoft.com/office/powerpoint/2010/main" val="1024086991"/>
+      </p:ext>
+    </p:extLst>
+  </p:cSld>
+  <p:clrMapOvr>
+    <a:masterClrMapping/>
+  </p:clrMapOvr>
+</p:notes>
+</file>
+
+<file path=ppt/notesSlides/notesSlide12.xml><?xml version="1.0" encoding="utf-8"?>
+<p:notes xmlns:a="http://schemas.openxmlformats.org/drawingml/2006/main" xmlns:r="http://schemas.openxmlformats.org/officeDocument/2006/relationships" xmlns:p="http://schemas.openxmlformats.org/presentationml/2006/main">
+  <p:cSld>
+    <p:spTree>
+      <p:nvGrpSpPr>
+        <p:cNvPr id="1" name=""/>
+        <p:cNvGrpSpPr/>
+        <p:nvPr/>
+      </p:nvGrpSpPr>
+      <p:grpSpPr>
+        <a:xfrm>
+          <a:off x="0" y="0"/>
+          <a:ext cx="0" cy="0"/>
+          <a:chOff x="0" y="0"/>
+          <a:chExt cx="0" cy="0"/>
+        </a:xfrm>
+      </p:grpSpPr>
+      <p:sp>
+        <p:nvSpPr>
+          <p:cNvPr id="2" name="Slide Image Placeholder 1"/>
+          <p:cNvSpPr>
+            <a:spLocks noGrp="1" noRot="1" noChangeAspect="1"/>
+          </p:cNvSpPr>
+          <p:nvPr>
+            <p:ph type="sldImg"/>
+          </p:nvPr>
+        </p:nvSpPr>
+        <p:spPr/>
+      </p:sp>
+      <p:sp>
+        <p:nvSpPr>
+          <p:cNvPr id="3" name="Notes Placeholder 2"/>
+          <p:cNvSpPr>
+            <a:spLocks noGrp="1"/>
+          </p:cNvSpPr>
+          <p:nvPr>
+            <p:ph type="body" idx="1"/>
+          </p:nvPr>
+        </p:nvSpPr>
+        <p:spPr/>
+        <p:txBody>
+          <a:bodyPr/>
+          <a:lstStyle/>
+          <a:p>
+            <a:r>
+              <a:rPr lang="en-US" dirty="0"/>
+              <a:t/>
+            </a:r>
+            <a:endParaRPr lang="en-US" dirty="0"/>
+          </a:p>
+        </p:txBody>
+      </p:sp>
+      <p:sp>
+        <p:nvSpPr>
+          <p:cNvPr id="4" name="Slide Number Placeholder 3"/>
+          <p:cNvSpPr>
+            <a:spLocks noGrp="1"/>
+          </p:cNvSpPr>
+          <p:nvPr>
+            <p:ph type="sldNum" sz="quarter" idx="10"/>
+          </p:nvPr>
+        </p:nvSpPr>
+        <p:spPr/>
+        <p:txBody>
+          <a:bodyPr/>
+          <a:lstStyle/>
+          <a:p>
+            <a:fld id="{F7021451-1387-4CA6-816F-3879F97B5CBC}" type="slidenum">
+              <a:rPr lang="en-US"/>
+              <a:t>12</a:t>
             </a:fld>
             <a:endParaRPr lang="en-US"/>
           </a:p>
@@ -2594,6 +2683,1210 @@
                   <a:schemeClr val="tx2"/>
                 </a:solidFill>
               </a:rPr>
+              <a:t>Langkah tiga bulan pertama</a:t>
+            </a:r>
+            <a:endParaRPr lang="en-US" sz="2800" dirty="0"/>
+          </a:p>
+        </p:txBody>
+      </p:sp>
+      <p:graphicFrame>
+        <p:nvGraphicFramePr>
+          <p:cNvPr id="11" name="Table 0"/>
+          <p:cNvGraphicFramePr>
+            <a:graphicFrameLocks noGrp="1"/>
+          </p:cNvGraphicFramePr>
+          <p:nvPr>
+            <p:extLst>
+              <p:ext uri="{D42A27DB-BD31-4B8C-83A1-F6EECF244321}">
+                <p14:modId xmlns:p14="http://schemas.microsoft.com/office/powerpoint/2010/main" val="1579011935"/>
+              </p:ext>
+            </p:extLst>
+          </p:nvPr>
+        </p:nvGraphicFramePr>
+        <p:xfrm>
+          <a:off x="548640" y="1554480"/>
+          <a:ext cx="11064240" cy="914400"/>
+        </p:xfrm>
+        <a:graphic>
+          <a:graphicData uri="http://schemas.openxmlformats.org/drawingml/2006/table">
+            <a:tbl>
+              <a:tblPr/>
+              <a:tblGrid>
+                <a:gridCol w="1645920"/>
+                <a:gridCol w="6035040"/>
+                <a:gridCol w="3383280"/>
+              </a:tblGrid>
+              <a:tr h="658368">
+                <a:tc>
+                  <a:txBody>
+                    <a:bodyPr/>
+                    <a:lstStyle/>
+                    <a:p>
+                      <a:pPr indent="0" marL="0">
+                        <a:buNone/>
+                      </a:pPr>
+                      <a:r>
+                        <a:rPr lang="en-US" sz="1600" b="1" dirty="0">
+                          <a:solidFill>
+                            <a:schemeClr val="tx1"/>
+                          </a:solidFill>
+                        </a:rPr>
+                        <a:t>Waktu</a:t>
+                      </a:r>
+                      <a:endParaRPr lang="en-US" sz="1600" dirty="0"/>
+                    </a:p>
+                  </a:txBody>
+                  <a:tcPr marL="101600" marR="101600" marT="63500" marB="63500" anchor="ctr">
+                    <a:lnL w="9525" cap="flat" cmpd="sng" algn="ctr">
+                      <a:solidFill>
+                        <a:srgbClr val="A6A6A6"/>
+                      </a:solidFill>
+                      <a:prstDash val="solid"/>
+                      <a:round/>
+                      <a:headEnd type="none" w="med" len="med"/>
+                      <a:tailEnd type="none" w="med" len="med"/>
+                    </a:lnL>
+                    <a:lnR w="9525" cap="flat" cmpd="sng" algn="ctr">
+                      <a:solidFill>
+                        <a:srgbClr val="A6A6A6"/>
+                      </a:solidFill>
+                      <a:prstDash val="solid"/>
+                      <a:round/>
+                      <a:headEnd type="none" w="med" len="med"/>
+                      <a:tailEnd type="none" w="med" len="med"/>
+                    </a:lnR>
+                    <a:lnT w="9525" cap="flat" cmpd="sng" algn="ctr">
+                      <a:solidFill>
+                        <a:srgbClr val="A6A6A6"/>
+                      </a:solidFill>
+                      <a:prstDash val="solid"/>
+                      <a:round/>
+                      <a:headEnd type="none" w="med" len="med"/>
+                      <a:tailEnd type="none" w="med" len="med"/>
+                    </a:lnT>
+                    <a:lnB w="9525" cap="flat" cmpd="sng" algn="ctr">
+                      <a:solidFill>
+                        <a:srgbClr val="A6A6A6"/>
+                      </a:solidFill>
+                      <a:prstDash val="solid"/>
+                      <a:round/>
+                      <a:headEnd type="none" w="med" len="med"/>
+                      <a:tailEnd type="none" w="med" len="med"/>
+                    </a:lnB>
+                    <a:solidFill>
+                      <a:srgbClr val="D9D9D9"/>
+                    </a:solidFill>
+                  </a:tcPr>
+                </a:tc>
+                <a:tc>
+                  <a:txBody>
+                    <a:bodyPr/>
+                    <a:lstStyle/>
+                    <a:p>
+                      <a:pPr indent="0" marL="0">
+                        <a:buNone/>
+                      </a:pPr>
+                      <a:r>
+                        <a:rPr lang="en-US" sz="1600" b="1" dirty="0">
+                          <a:solidFill>
+                            <a:schemeClr val="tx1"/>
+                          </a:solidFill>
+                        </a:rPr>
+                        <a:t>Kegiatan</a:t>
+                      </a:r>
+                      <a:endParaRPr lang="en-US" sz="1600" dirty="0"/>
+                    </a:p>
+                  </a:txBody>
+                  <a:tcPr marL="101600" marR="101600" marT="63500" marB="63500" anchor="ctr">
+                    <a:lnL w="9525" cap="flat" cmpd="sng" algn="ctr">
+                      <a:solidFill>
+                        <a:srgbClr val="A6A6A6"/>
+                      </a:solidFill>
+                      <a:prstDash val="solid"/>
+                      <a:round/>
+                      <a:headEnd type="none" w="med" len="med"/>
+                      <a:tailEnd type="none" w="med" len="med"/>
+                    </a:lnL>
+                    <a:lnR w="9525" cap="flat" cmpd="sng" algn="ctr">
+                      <a:solidFill>
+                        <a:srgbClr val="A6A6A6"/>
+                      </a:solidFill>
+                      <a:prstDash val="solid"/>
+                      <a:round/>
+                      <a:headEnd type="none" w="med" len="med"/>
+                      <a:tailEnd type="none" w="med" len="med"/>
+                    </a:lnR>
+                    <a:lnT w="9525" cap="flat" cmpd="sng" algn="ctr">
+                      <a:solidFill>
+                        <a:srgbClr val="A6A6A6"/>
+                      </a:solidFill>
+                      <a:prstDash val="solid"/>
+                      <a:round/>
+                      <a:headEnd type="none" w="med" len="med"/>
+                      <a:tailEnd type="none" w="med" len="med"/>
+                    </a:lnT>
+                    <a:lnB w="9525" cap="flat" cmpd="sng" algn="ctr">
+                      <a:solidFill>
+                        <a:srgbClr val="A6A6A6"/>
+                      </a:solidFill>
+                      <a:prstDash val="solid"/>
+                      <a:round/>
+                      <a:headEnd type="none" w="med" len="med"/>
+                      <a:tailEnd type="none" w="med" len="med"/>
+                    </a:lnB>
+                    <a:solidFill>
+                      <a:srgbClr val="D9D9D9"/>
+                    </a:solidFill>
+                  </a:tcPr>
+                </a:tc>
+                <a:tc>
+                  <a:txBody>
+                    <a:bodyPr/>
+                    <a:lstStyle/>
+                    <a:p>
+                      <a:pPr indent="0" marL="0">
+                        <a:buNone/>
+                      </a:pPr>
+                      <a:r>
+                        <a:rPr lang="en-US" sz="1600" b="1" dirty="0">
+                          <a:solidFill>
+                            <a:schemeClr val="tx1"/>
+                          </a:solidFill>
+                        </a:rPr>
+                        <a:t>Pelaksana</a:t>
+                      </a:r>
+                      <a:endParaRPr lang="en-US" sz="1600" dirty="0"/>
+                    </a:p>
+                  </a:txBody>
+                  <a:tcPr marL="101600" marR="101600" marT="63500" marB="63500" anchor="ctr">
+                    <a:lnL w="9525" cap="flat" cmpd="sng" algn="ctr">
+                      <a:solidFill>
+                        <a:srgbClr val="A6A6A6"/>
+                      </a:solidFill>
+                      <a:prstDash val="solid"/>
+                      <a:round/>
+                      <a:headEnd type="none" w="med" len="med"/>
+                      <a:tailEnd type="none" w="med" len="med"/>
+                    </a:lnL>
+                    <a:lnR w="9525" cap="flat" cmpd="sng" algn="ctr">
+                      <a:solidFill>
+                        <a:srgbClr val="A6A6A6"/>
+                      </a:solidFill>
+                      <a:prstDash val="solid"/>
+                      <a:round/>
+                      <a:headEnd type="none" w="med" len="med"/>
+                      <a:tailEnd type="none" w="med" len="med"/>
+                    </a:lnR>
+                    <a:lnT w="9525" cap="flat" cmpd="sng" algn="ctr">
+                      <a:solidFill>
+                        <a:srgbClr val="A6A6A6"/>
+                      </a:solidFill>
+                      <a:prstDash val="solid"/>
+                      <a:round/>
+                      <a:headEnd type="none" w="med" len="med"/>
+                      <a:tailEnd type="none" w="med" len="med"/>
+                    </a:lnT>
+                    <a:lnB w="9525" cap="flat" cmpd="sng" algn="ctr">
+                      <a:solidFill>
+                        <a:srgbClr val="A6A6A6"/>
+                      </a:solidFill>
+                      <a:prstDash val="solid"/>
+                      <a:round/>
+                      <a:headEnd type="none" w="med" len="med"/>
+                      <a:tailEnd type="none" w="med" len="med"/>
+                    </a:lnB>
+                    <a:solidFill>
+                      <a:srgbClr val="D9D9D9"/>
+                    </a:solidFill>
+                  </a:tcPr>
+                </a:tc>
+              </a:tr>
+              <a:tr h="658368">
+                <a:tc>
+                  <a:txBody>
+                    <a:bodyPr/>
+                    <a:lstStyle/>
+                    <a:p>
+                      <a:pPr indent="0" marL="0">
+                        <a:buNone/>
+                      </a:pPr>
+                      <a:r>
+                        <a:rPr lang="en-US" sz="1600" dirty="0">
+                          <a:solidFill>
+                            <a:schemeClr val="tx1"/>
+                          </a:solidFill>
+                        </a:rPr>
+                        <a:t>Bulan 1</a:t>
+                      </a:r>
+                      <a:endParaRPr lang="en-US" sz="1600" dirty="0"/>
+                    </a:p>
+                  </a:txBody>
+                  <a:tcPr marL="101600" marR="101600" marT="63500" marB="63500" anchor="ctr">
+                    <a:lnL w="9525" cap="flat" cmpd="sng" algn="ctr">
+                      <a:solidFill>
+                        <a:srgbClr val="A6A6A6"/>
+                      </a:solidFill>
+                      <a:prstDash val="solid"/>
+                      <a:round/>
+                      <a:headEnd type="none" w="med" len="med"/>
+                      <a:tailEnd type="none" w="med" len="med"/>
+                    </a:lnL>
+                    <a:lnR w="9525" cap="flat" cmpd="sng" algn="ctr">
+                      <a:solidFill>
+                        <a:srgbClr val="A6A6A6"/>
+                      </a:solidFill>
+                      <a:prstDash val="solid"/>
+                      <a:round/>
+                      <a:headEnd type="none" w="med" len="med"/>
+                      <a:tailEnd type="none" w="med" len="med"/>
+                    </a:lnR>
+                    <a:lnT w="9525" cap="flat" cmpd="sng" algn="ctr">
+                      <a:solidFill>
+                        <a:srgbClr val="A6A6A6"/>
+                      </a:solidFill>
+                      <a:prstDash val="solid"/>
+                      <a:round/>
+                      <a:headEnd type="none" w="med" len="med"/>
+                      <a:tailEnd type="none" w="med" len="med"/>
+                    </a:lnT>
+                    <a:lnB w="9525" cap="flat" cmpd="sng" algn="ctr">
+                      <a:solidFill>
+                        <a:srgbClr val="A6A6A6"/>
+                      </a:solidFill>
+                      <a:prstDash val="solid"/>
+                      <a:round/>
+                      <a:headEnd type="none" w="med" len="med"/>
+                      <a:tailEnd type="none" w="med" len="med"/>
+                    </a:lnB>
+                  </a:tcPr>
+                </a:tc>
+                <a:tc>
+                  <a:txBody>
+                    <a:bodyPr/>
+                    <a:lstStyle/>
+                    <a:p>
+                      <a:pPr indent="0" marL="0">
+                        <a:buNone/>
+                      </a:pPr>
+                      <a:r>
+                        <a:rPr lang="en-US" sz="1600" dirty="0">
+                          <a:solidFill>
+                            <a:schemeClr val="tx1"/>
+                          </a:solidFill>
+                        </a:rPr>
+                        <a:t>Pemeriksaan manual 50 unggahan untuk menguji ketepatan klasifikasi</a:t>
+                      </a:r>
+                      <a:endParaRPr lang="en-US" sz="1600" dirty="0"/>
+                    </a:p>
+                  </a:txBody>
+                  <a:tcPr marL="101600" marR="101600" marT="63500" marB="63500" anchor="ctr">
+                    <a:lnL w="9525" cap="flat" cmpd="sng" algn="ctr">
+                      <a:solidFill>
+                        <a:srgbClr val="A6A6A6"/>
+                      </a:solidFill>
+                      <a:prstDash val="solid"/>
+                      <a:round/>
+                      <a:headEnd type="none" w="med" len="med"/>
+                      <a:tailEnd type="none" w="med" len="med"/>
+                    </a:lnL>
+                    <a:lnR w="9525" cap="flat" cmpd="sng" algn="ctr">
+                      <a:solidFill>
+                        <a:srgbClr val="A6A6A6"/>
+                      </a:solidFill>
+                      <a:prstDash val="solid"/>
+                      <a:round/>
+                      <a:headEnd type="none" w="med" len="med"/>
+                      <a:tailEnd type="none" w="med" len="med"/>
+                    </a:lnR>
+                    <a:lnT w="9525" cap="flat" cmpd="sng" algn="ctr">
+                      <a:solidFill>
+                        <a:srgbClr val="A6A6A6"/>
+                      </a:solidFill>
+                      <a:prstDash val="solid"/>
+                      <a:round/>
+                      <a:headEnd type="none" w="med" len="med"/>
+                      <a:tailEnd type="none" w="med" len="med"/>
+                    </a:lnT>
+                    <a:lnB w="9525" cap="flat" cmpd="sng" algn="ctr">
+                      <a:solidFill>
+                        <a:srgbClr val="A6A6A6"/>
+                      </a:solidFill>
+                      <a:prstDash val="solid"/>
+                      <a:round/>
+                      <a:headEnd type="none" w="med" len="med"/>
+                      <a:tailEnd type="none" w="med" len="med"/>
+                    </a:lnB>
+                  </a:tcPr>
+                </a:tc>
+                <a:tc>
+                  <a:txBody>
+                    <a:bodyPr/>
+                    <a:lstStyle/>
+                    <a:p>
+                      <a:pPr indent="0" marL="0">
+                        <a:buNone/>
+                      </a:pPr>
+                      <a:r>
+                        <a:rPr lang="en-US" sz="1600" dirty="0">
+                          <a:solidFill>
+                            <a:schemeClr val="tx1"/>
+                          </a:solidFill>
+                        </a:rPr>
+                        <a:t>Pengelola akun, dibantu magang</a:t>
+                      </a:r>
+                      <a:endParaRPr lang="en-US" sz="1600" dirty="0"/>
+                    </a:p>
+                  </a:txBody>
+                  <a:tcPr marL="101600" marR="101600" marT="63500" marB="63500" anchor="ctr">
+                    <a:lnL w="9525" cap="flat" cmpd="sng" algn="ctr">
+                      <a:solidFill>
+                        <a:srgbClr val="A6A6A6"/>
+                      </a:solidFill>
+                      <a:prstDash val="solid"/>
+                      <a:round/>
+                      <a:headEnd type="none" w="med" len="med"/>
+                      <a:tailEnd type="none" w="med" len="med"/>
+                    </a:lnL>
+                    <a:lnR w="9525" cap="flat" cmpd="sng" algn="ctr">
+                      <a:solidFill>
+                        <a:srgbClr val="A6A6A6"/>
+                      </a:solidFill>
+                      <a:prstDash val="solid"/>
+                      <a:round/>
+                      <a:headEnd type="none" w="med" len="med"/>
+                      <a:tailEnd type="none" w="med" len="med"/>
+                    </a:lnR>
+                    <a:lnT w="9525" cap="flat" cmpd="sng" algn="ctr">
+                      <a:solidFill>
+                        <a:srgbClr val="A6A6A6"/>
+                      </a:solidFill>
+                      <a:prstDash val="solid"/>
+                      <a:round/>
+                      <a:headEnd type="none" w="med" len="med"/>
+                      <a:tailEnd type="none" w="med" len="med"/>
+                    </a:lnT>
+                    <a:lnB w="9525" cap="flat" cmpd="sng" algn="ctr">
+                      <a:solidFill>
+                        <a:srgbClr val="A6A6A6"/>
+                      </a:solidFill>
+                      <a:prstDash val="solid"/>
+                      <a:round/>
+                      <a:headEnd type="none" w="med" len="med"/>
+                      <a:tailEnd type="none" w="med" len="med"/>
+                    </a:lnB>
+                  </a:tcPr>
+                </a:tc>
+              </a:tr>
+              <a:tr h="658368">
+                <a:tc>
+                  <a:txBody>
+                    <a:bodyPr/>
+                    <a:lstStyle/>
+                    <a:p>
+                      <a:pPr indent="0" marL="0">
+                        <a:buNone/>
+                      </a:pPr>
+                      <a:r>
+                        <a:rPr lang="en-US" sz="1600" dirty="0">
+                          <a:solidFill>
+                            <a:schemeClr val="tx1"/>
+                          </a:solidFill>
+                        </a:rPr>
+                        <a:t>Bulan 1</a:t>
+                      </a:r>
+                      <a:endParaRPr lang="en-US" sz="1600" dirty="0"/>
+                    </a:p>
+                  </a:txBody>
+                  <a:tcPr marL="101600" marR="101600" marT="63500" marB="63500" anchor="ctr">
+                    <a:lnL w="9525" cap="flat" cmpd="sng" algn="ctr">
+                      <a:solidFill>
+                        <a:srgbClr val="A6A6A6"/>
+                      </a:solidFill>
+                      <a:prstDash val="solid"/>
+                      <a:round/>
+                      <a:headEnd type="none" w="med" len="med"/>
+                      <a:tailEnd type="none" w="med" len="med"/>
+                    </a:lnL>
+                    <a:lnR w="9525" cap="flat" cmpd="sng" algn="ctr">
+                      <a:solidFill>
+                        <a:srgbClr val="A6A6A6"/>
+                      </a:solidFill>
+                      <a:prstDash val="solid"/>
+                      <a:round/>
+                      <a:headEnd type="none" w="med" len="med"/>
+                      <a:tailEnd type="none" w="med" len="med"/>
+                    </a:lnR>
+                    <a:lnT w="9525" cap="flat" cmpd="sng" algn="ctr">
+                      <a:solidFill>
+                        <a:srgbClr val="A6A6A6"/>
+                      </a:solidFill>
+                      <a:prstDash val="solid"/>
+                      <a:round/>
+                      <a:headEnd type="none" w="med" len="med"/>
+                      <a:tailEnd type="none" w="med" len="med"/>
+                    </a:lnT>
+                    <a:lnB w="9525" cap="flat" cmpd="sng" algn="ctr">
+                      <a:solidFill>
+                        <a:srgbClr val="A6A6A6"/>
+                      </a:solidFill>
+                      <a:prstDash val="solid"/>
+                      <a:round/>
+                      <a:headEnd type="none" w="med" len="med"/>
+                      <a:tailEnd type="none" w="med" len="med"/>
+                    </a:lnB>
+                  </a:tcPr>
+                </a:tc>
+                <a:tc>
+                  <a:txBody>
+                    <a:bodyPr/>
+                    <a:lstStyle/>
+                    <a:p>
+                      <a:pPr indent="0" marL="0">
+                        <a:buNone/>
+                      </a:pPr>
+                      <a:r>
+                        <a:rPr lang="en-US" sz="1600" dirty="0">
+                          <a:solidFill>
+                            <a:schemeClr val="tx1"/>
+                          </a:solidFill>
+                        </a:rPr>
+                        <a:t>Pengambilan data asal pengikut dan jangkauan (Instagram Insights)</a:t>
+                      </a:r>
+                      <a:endParaRPr lang="en-US" sz="1600" dirty="0"/>
+                    </a:p>
+                  </a:txBody>
+                  <a:tcPr marL="101600" marR="101600" marT="63500" marB="63500" anchor="ctr">
+                    <a:lnL w="9525" cap="flat" cmpd="sng" algn="ctr">
+                      <a:solidFill>
+                        <a:srgbClr val="A6A6A6"/>
+                      </a:solidFill>
+                      <a:prstDash val="solid"/>
+                      <a:round/>
+                      <a:headEnd type="none" w="med" len="med"/>
+                      <a:tailEnd type="none" w="med" len="med"/>
+                    </a:lnL>
+                    <a:lnR w="9525" cap="flat" cmpd="sng" algn="ctr">
+                      <a:solidFill>
+                        <a:srgbClr val="A6A6A6"/>
+                      </a:solidFill>
+                      <a:prstDash val="solid"/>
+                      <a:round/>
+                      <a:headEnd type="none" w="med" len="med"/>
+                      <a:tailEnd type="none" w="med" len="med"/>
+                    </a:lnR>
+                    <a:lnT w="9525" cap="flat" cmpd="sng" algn="ctr">
+                      <a:solidFill>
+                        <a:srgbClr val="A6A6A6"/>
+                      </a:solidFill>
+                      <a:prstDash val="solid"/>
+                      <a:round/>
+                      <a:headEnd type="none" w="med" len="med"/>
+                      <a:tailEnd type="none" w="med" len="med"/>
+                    </a:lnT>
+                    <a:lnB w="9525" cap="flat" cmpd="sng" algn="ctr">
+                      <a:solidFill>
+                        <a:srgbClr val="A6A6A6"/>
+                      </a:solidFill>
+                      <a:prstDash val="solid"/>
+                      <a:round/>
+                      <a:headEnd type="none" w="med" len="med"/>
+                      <a:tailEnd type="none" w="med" len="med"/>
+                    </a:lnB>
+                  </a:tcPr>
+                </a:tc>
+                <a:tc>
+                  <a:txBody>
+                    <a:bodyPr/>
+                    <a:lstStyle/>
+                    <a:p>
+                      <a:pPr indent="0" marL="0">
+                        <a:buNone/>
+                      </a:pPr>
+                      <a:r>
+                        <a:rPr lang="en-US" sz="1600" dirty="0">
+                          <a:solidFill>
+                            <a:schemeClr val="tx1"/>
+                          </a:solidFill>
+                        </a:rPr>
+                        <a:t>Pengelola akun</a:t>
+                      </a:r>
+                      <a:endParaRPr lang="en-US" sz="1600" dirty="0"/>
+                    </a:p>
+                  </a:txBody>
+                  <a:tcPr marL="101600" marR="101600" marT="63500" marB="63500" anchor="ctr">
+                    <a:lnL w="9525" cap="flat" cmpd="sng" algn="ctr">
+                      <a:solidFill>
+                        <a:srgbClr val="A6A6A6"/>
+                      </a:solidFill>
+                      <a:prstDash val="solid"/>
+                      <a:round/>
+                      <a:headEnd type="none" w="med" len="med"/>
+                      <a:tailEnd type="none" w="med" len="med"/>
+                    </a:lnL>
+                    <a:lnR w="9525" cap="flat" cmpd="sng" algn="ctr">
+                      <a:solidFill>
+                        <a:srgbClr val="A6A6A6"/>
+                      </a:solidFill>
+                      <a:prstDash val="solid"/>
+                      <a:round/>
+                      <a:headEnd type="none" w="med" len="med"/>
+                      <a:tailEnd type="none" w="med" len="med"/>
+                    </a:lnR>
+                    <a:lnT w="9525" cap="flat" cmpd="sng" algn="ctr">
+                      <a:solidFill>
+                        <a:srgbClr val="A6A6A6"/>
+                      </a:solidFill>
+                      <a:prstDash val="solid"/>
+                      <a:round/>
+                      <a:headEnd type="none" w="med" len="med"/>
+                      <a:tailEnd type="none" w="med" len="med"/>
+                    </a:lnT>
+                    <a:lnB w="9525" cap="flat" cmpd="sng" algn="ctr">
+                      <a:solidFill>
+                        <a:srgbClr val="A6A6A6"/>
+                      </a:solidFill>
+                      <a:prstDash val="solid"/>
+                      <a:round/>
+                      <a:headEnd type="none" w="med" len="med"/>
+                      <a:tailEnd type="none" w="med" len="med"/>
+                    </a:lnB>
+                  </a:tcPr>
+                </a:tc>
+              </a:tr>
+              <a:tr h="658368">
+                <a:tc>
+                  <a:txBody>
+                    <a:bodyPr/>
+                    <a:lstStyle/>
+                    <a:p>
+                      <a:pPr indent="0" marL="0">
+                        <a:buNone/>
+                      </a:pPr>
+                      <a:r>
+                        <a:rPr lang="en-US" sz="1600" dirty="0">
+                          <a:solidFill>
+                            <a:schemeClr val="tx1"/>
+                          </a:solidFill>
+                        </a:rPr>
+                        <a:t>Bulan 1</a:t>
+                      </a:r>
+                      <a:endParaRPr lang="en-US" sz="1600" dirty="0"/>
+                    </a:p>
+                  </a:txBody>
+                  <a:tcPr marL="101600" marR="101600" marT="63500" marB="63500" anchor="ctr">
+                    <a:lnL w="9525" cap="flat" cmpd="sng" algn="ctr">
+                      <a:solidFill>
+                        <a:srgbClr val="A6A6A6"/>
+                      </a:solidFill>
+                      <a:prstDash val="solid"/>
+                      <a:round/>
+                      <a:headEnd type="none" w="med" len="med"/>
+                      <a:tailEnd type="none" w="med" len="med"/>
+                    </a:lnL>
+                    <a:lnR w="9525" cap="flat" cmpd="sng" algn="ctr">
+                      <a:solidFill>
+                        <a:srgbClr val="A6A6A6"/>
+                      </a:solidFill>
+                      <a:prstDash val="solid"/>
+                      <a:round/>
+                      <a:headEnd type="none" w="med" len="med"/>
+                      <a:tailEnd type="none" w="med" len="med"/>
+                    </a:lnR>
+                    <a:lnT w="9525" cap="flat" cmpd="sng" algn="ctr">
+                      <a:solidFill>
+                        <a:srgbClr val="A6A6A6"/>
+                      </a:solidFill>
+                      <a:prstDash val="solid"/>
+                      <a:round/>
+                      <a:headEnd type="none" w="med" len="med"/>
+                      <a:tailEnd type="none" w="med" len="med"/>
+                    </a:lnT>
+                    <a:lnB w="9525" cap="flat" cmpd="sng" algn="ctr">
+                      <a:solidFill>
+                        <a:srgbClr val="A6A6A6"/>
+                      </a:solidFill>
+                      <a:prstDash val="solid"/>
+                      <a:round/>
+                      <a:headEnd type="none" w="med" len="med"/>
+                      <a:tailEnd type="none" w="med" len="med"/>
+                    </a:lnB>
+                  </a:tcPr>
+                </a:tc>
+                <a:tc>
+                  <a:txBody>
+                    <a:bodyPr/>
+                    <a:lstStyle/>
+                    <a:p>
+                      <a:pPr indent="0" marL="0">
+                        <a:buNone/>
+                      </a:pPr>
+                      <a:r>
+                        <a:rPr lang="en-US" sz="1600" dirty="0">
+                          <a:solidFill>
+                            <a:schemeClr val="tx1"/>
+                          </a:solidFill>
+                        </a:rPr>
+                        <a:t>Penetapan proporsi awal kategori A, B, C</a:t>
+                      </a:r>
+                      <a:endParaRPr lang="en-US" sz="1600" dirty="0"/>
+                    </a:p>
+                  </a:txBody>
+                  <a:tcPr marL="101600" marR="101600" marT="63500" marB="63500" anchor="ctr">
+                    <a:lnL w="9525" cap="flat" cmpd="sng" algn="ctr">
+                      <a:solidFill>
+                        <a:srgbClr val="A6A6A6"/>
+                      </a:solidFill>
+                      <a:prstDash val="solid"/>
+                      <a:round/>
+                      <a:headEnd type="none" w="med" len="med"/>
+                      <a:tailEnd type="none" w="med" len="med"/>
+                    </a:lnL>
+                    <a:lnR w="9525" cap="flat" cmpd="sng" algn="ctr">
+                      <a:solidFill>
+                        <a:srgbClr val="A6A6A6"/>
+                      </a:solidFill>
+                      <a:prstDash val="solid"/>
+                      <a:round/>
+                      <a:headEnd type="none" w="med" len="med"/>
+                      <a:tailEnd type="none" w="med" len="med"/>
+                    </a:lnR>
+                    <a:lnT w="9525" cap="flat" cmpd="sng" algn="ctr">
+                      <a:solidFill>
+                        <a:srgbClr val="A6A6A6"/>
+                      </a:solidFill>
+                      <a:prstDash val="solid"/>
+                      <a:round/>
+                      <a:headEnd type="none" w="med" len="med"/>
+                      <a:tailEnd type="none" w="med" len="med"/>
+                    </a:lnT>
+                    <a:lnB w="9525" cap="flat" cmpd="sng" algn="ctr">
+                      <a:solidFill>
+                        <a:srgbClr val="A6A6A6"/>
+                      </a:solidFill>
+                      <a:prstDash val="solid"/>
+                      <a:round/>
+                      <a:headEnd type="none" w="med" len="med"/>
+                      <a:tailEnd type="none" w="med" len="med"/>
+                    </a:lnB>
+                  </a:tcPr>
+                </a:tc>
+                <a:tc>
+                  <a:txBody>
+                    <a:bodyPr/>
+                    <a:lstStyle/>
+                    <a:p>
+                      <a:pPr indent="0" marL="0">
+                        <a:buNone/>
+                      </a:pPr>
+                      <a:r>
+                        <a:rPr lang="en-US" sz="1600" dirty="0">
+                          <a:solidFill>
+                            <a:schemeClr val="tx1"/>
+                          </a:solidFill>
+                        </a:rPr>
+                        <a:t>Pimpinan</a:t>
+                      </a:r>
+                      <a:endParaRPr lang="en-US" sz="1600" dirty="0"/>
+                    </a:p>
+                  </a:txBody>
+                  <a:tcPr marL="101600" marR="101600" marT="63500" marB="63500" anchor="ctr">
+                    <a:lnL w="9525" cap="flat" cmpd="sng" algn="ctr">
+                      <a:solidFill>
+                        <a:srgbClr val="A6A6A6"/>
+                      </a:solidFill>
+                      <a:prstDash val="solid"/>
+                      <a:round/>
+                      <a:headEnd type="none" w="med" len="med"/>
+                      <a:tailEnd type="none" w="med" len="med"/>
+                    </a:lnL>
+                    <a:lnR w="9525" cap="flat" cmpd="sng" algn="ctr">
+                      <a:solidFill>
+                        <a:srgbClr val="A6A6A6"/>
+                      </a:solidFill>
+                      <a:prstDash val="solid"/>
+                      <a:round/>
+                      <a:headEnd type="none" w="med" len="med"/>
+                      <a:tailEnd type="none" w="med" len="med"/>
+                    </a:lnR>
+                    <a:lnT w="9525" cap="flat" cmpd="sng" algn="ctr">
+                      <a:solidFill>
+                        <a:srgbClr val="A6A6A6"/>
+                      </a:solidFill>
+                      <a:prstDash val="solid"/>
+                      <a:round/>
+                      <a:headEnd type="none" w="med" len="med"/>
+                      <a:tailEnd type="none" w="med" len="med"/>
+                    </a:lnT>
+                    <a:lnB w="9525" cap="flat" cmpd="sng" algn="ctr">
+                      <a:solidFill>
+                        <a:srgbClr val="A6A6A6"/>
+                      </a:solidFill>
+                      <a:prstDash val="solid"/>
+                      <a:round/>
+                      <a:headEnd type="none" w="med" len="med"/>
+                      <a:tailEnd type="none" w="med" len="med"/>
+                    </a:lnB>
+                  </a:tcPr>
+                </a:tc>
+              </a:tr>
+              <a:tr h="658368">
+                <a:tc>
+                  <a:txBody>
+                    <a:bodyPr/>
+                    <a:lstStyle/>
+                    <a:p>
+                      <a:pPr indent="0" marL="0">
+                        <a:buNone/>
+                      </a:pPr>
+                      <a:r>
+                        <a:rPr lang="en-US" sz="1600" dirty="0">
+                          <a:solidFill>
+                            <a:schemeClr val="tx1"/>
+                          </a:solidFill>
+                        </a:rPr>
+                        <a:t>Bulan 2–3</a:t>
+                      </a:r>
+                      <a:endParaRPr lang="en-US" sz="1600" dirty="0"/>
+                    </a:p>
+                  </a:txBody>
+                  <a:tcPr marL="101600" marR="101600" marT="63500" marB="63500" anchor="ctr">
+                    <a:lnL w="9525" cap="flat" cmpd="sng" algn="ctr">
+                      <a:solidFill>
+                        <a:srgbClr val="A6A6A6"/>
+                      </a:solidFill>
+                      <a:prstDash val="solid"/>
+                      <a:round/>
+                      <a:headEnd type="none" w="med" len="med"/>
+                      <a:tailEnd type="none" w="med" len="med"/>
+                    </a:lnL>
+                    <a:lnR w="9525" cap="flat" cmpd="sng" algn="ctr">
+                      <a:solidFill>
+                        <a:srgbClr val="A6A6A6"/>
+                      </a:solidFill>
+                      <a:prstDash val="solid"/>
+                      <a:round/>
+                      <a:headEnd type="none" w="med" len="med"/>
+                      <a:tailEnd type="none" w="med" len="med"/>
+                    </a:lnR>
+                    <a:lnT w="9525" cap="flat" cmpd="sng" algn="ctr">
+                      <a:solidFill>
+                        <a:srgbClr val="A6A6A6"/>
+                      </a:solidFill>
+                      <a:prstDash val="solid"/>
+                      <a:round/>
+                      <a:headEnd type="none" w="med" len="med"/>
+                      <a:tailEnd type="none" w="med" len="med"/>
+                    </a:lnT>
+                    <a:lnB w="9525" cap="flat" cmpd="sng" algn="ctr">
+                      <a:solidFill>
+                        <a:srgbClr val="A6A6A6"/>
+                      </a:solidFill>
+                      <a:prstDash val="solid"/>
+                      <a:round/>
+                      <a:headEnd type="none" w="med" len="med"/>
+                      <a:tailEnd type="none" w="med" len="med"/>
+                    </a:lnB>
+                  </a:tcPr>
+                </a:tc>
+                <a:tc>
+                  <a:txBody>
+                    <a:bodyPr/>
+                    <a:lstStyle/>
+                    <a:p>
+                      <a:pPr indent="0" marL="0">
+                        <a:buNone/>
+                      </a:pPr>
+                      <a:r>
+                        <a:rPr lang="en-US" sz="1600" dirty="0">
+                          <a:solidFill>
+                            <a:schemeClr val="tx1"/>
+                          </a:solidFill>
+                        </a:rPr>
+                        <a:t>Uji coba: setiap unggahan diberi kategori sebelum terbit; laporan bulanan</a:t>
+                      </a:r>
+                      <a:endParaRPr lang="en-US" sz="1600" dirty="0"/>
+                    </a:p>
+                  </a:txBody>
+                  <a:tcPr marL="101600" marR="101600" marT="63500" marB="63500" anchor="ctr">
+                    <a:lnL w="9525" cap="flat" cmpd="sng" algn="ctr">
+                      <a:solidFill>
+                        <a:srgbClr val="A6A6A6"/>
+                      </a:solidFill>
+                      <a:prstDash val="solid"/>
+                      <a:round/>
+                      <a:headEnd type="none" w="med" len="med"/>
+                      <a:tailEnd type="none" w="med" len="med"/>
+                    </a:lnL>
+                    <a:lnR w="9525" cap="flat" cmpd="sng" algn="ctr">
+                      <a:solidFill>
+                        <a:srgbClr val="A6A6A6"/>
+                      </a:solidFill>
+                      <a:prstDash val="solid"/>
+                      <a:round/>
+                      <a:headEnd type="none" w="med" len="med"/>
+                      <a:tailEnd type="none" w="med" len="med"/>
+                    </a:lnR>
+                    <a:lnT w="9525" cap="flat" cmpd="sng" algn="ctr">
+                      <a:solidFill>
+                        <a:srgbClr val="A6A6A6"/>
+                      </a:solidFill>
+                      <a:prstDash val="solid"/>
+                      <a:round/>
+                      <a:headEnd type="none" w="med" len="med"/>
+                      <a:tailEnd type="none" w="med" len="med"/>
+                    </a:lnT>
+                    <a:lnB w="9525" cap="flat" cmpd="sng" algn="ctr">
+                      <a:solidFill>
+                        <a:srgbClr val="A6A6A6"/>
+                      </a:solidFill>
+                      <a:prstDash val="solid"/>
+                      <a:round/>
+                      <a:headEnd type="none" w="med" len="med"/>
+                      <a:tailEnd type="none" w="med" len="med"/>
+                    </a:lnB>
+                  </a:tcPr>
+                </a:tc>
+                <a:tc>
+                  <a:txBody>
+                    <a:bodyPr/>
+                    <a:lstStyle/>
+                    <a:p>
+                      <a:pPr indent="0" marL="0">
+                        <a:buNone/>
+                      </a:pPr>
+                      <a:r>
+                        <a:rPr lang="en-US" sz="1600" dirty="0">
+                          <a:solidFill>
+                            <a:schemeClr val="tx1"/>
+                          </a:solidFill>
+                        </a:rPr>
+                        <a:t>Pengelola akun, dibantu magang</a:t>
+                      </a:r>
+                      <a:endParaRPr lang="en-US" sz="1600" dirty="0"/>
+                    </a:p>
+                  </a:txBody>
+                  <a:tcPr marL="101600" marR="101600" marT="63500" marB="63500" anchor="ctr">
+                    <a:lnL w="9525" cap="flat" cmpd="sng" algn="ctr">
+                      <a:solidFill>
+                        <a:srgbClr val="A6A6A6"/>
+                      </a:solidFill>
+                      <a:prstDash val="solid"/>
+                      <a:round/>
+                      <a:headEnd type="none" w="med" len="med"/>
+                      <a:tailEnd type="none" w="med" len="med"/>
+                    </a:lnL>
+                    <a:lnR w="9525" cap="flat" cmpd="sng" algn="ctr">
+                      <a:solidFill>
+                        <a:srgbClr val="A6A6A6"/>
+                      </a:solidFill>
+                      <a:prstDash val="solid"/>
+                      <a:round/>
+                      <a:headEnd type="none" w="med" len="med"/>
+                      <a:tailEnd type="none" w="med" len="med"/>
+                    </a:lnR>
+                    <a:lnT w="9525" cap="flat" cmpd="sng" algn="ctr">
+                      <a:solidFill>
+                        <a:srgbClr val="A6A6A6"/>
+                      </a:solidFill>
+                      <a:prstDash val="solid"/>
+                      <a:round/>
+                      <a:headEnd type="none" w="med" len="med"/>
+                      <a:tailEnd type="none" w="med" len="med"/>
+                    </a:lnT>
+                    <a:lnB w="9525" cap="flat" cmpd="sng" algn="ctr">
+                      <a:solidFill>
+                        <a:srgbClr val="A6A6A6"/>
+                      </a:solidFill>
+                      <a:prstDash val="solid"/>
+                      <a:round/>
+                      <a:headEnd type="none" w="med" len="med"/>
+                      <a:tailEnd type="none" w="med" len="med"/>
+                    </a:lnB>
+                  </a:tcPr>
+                </a:tc>
+              </a:tr>
+              <a:tr h="658368">
+                <a:tc>
+                  <a:txBody>
+                    <a:bodyPr/>
+                    <a:lstStyle/>
+                    <a:p>
+                      <a:pPr indent="0" marL="0">
+                        <a:buNone/>
+                      </a:pPr>
+                      <a:r>
+                        <a:rPr lang="en-US" sz="1600" dirty="0">
+                          <a:solidFill>
+                            <a:schemeClr val="tx1"/>
+                          </a:solidFill>
+                        </a:rPr>
+                        <a:t>Bulan 3</a:t>
+                      </a:r>
+                      <a:endParaRPr lang="en-US" sz="1600" dirty="0"/>
+                    </a:p>
+                  </a:txBody>
+                  <a:tcPr marL="101600" marR="101600" marT="63500" marB="63500" anchor="ctr">
+                    <a:lnL w="9525" cap="flat" cmpd="sng" algn="ctr">
+                      <a:solidFill>
+                        <a:srgbClr val="A6A6A6"/>
+                      </a:solidFill>
+                      <a:prstDash val="solid"/>
+                      <a:round/>
+                      <a:headEnd type="none" w="med" len="med"/>
+                      <a:tailEnd type="none" w="med" len="med"/>
+                    </a:lnL>
+                    <a:lnR w="9525" cap="flat" cmpd="sng" algn="ctr">
+                      <a:solidFill>
+                        <a:srgbClr val="A6A6A6"/>
+                      </a:solidFill>
+                      <a:prstDash val="solid"/>
+                      <a:round/>
+                      <a:headEnd type="none" w="med" len="med"/>
+                      <a:tailEnd type="none" w="med" len="med"/>
+                    </a:lnR>
+                    <a:lnT w="9525" cap="flat" cmpd="sng" algn="ctr">
+                      <a:solidFill>
+                        <a:srgbClr val="A6A6A6"/>
+                      </a:solidFill>
+                      <a:prstDash val="solid"/>
+                      <a:round/>
+                      <a:headEnd type="none" w="med" len="med"/>
+                      <a:tailEnd type="none" w="med" len="med"/>
+                    </a:lnT>
+                    <a:lnB w="9525" cap="flat" cmpd="sng" algn="ctr">
+                      <a:solidFill>
+                        <a:srgbClr val="A6A6A6"/>
+                      </a:solidFill>
+                      <a:prstDash val="solid"/>
+                      <a:round/>
+                      <a:headEnd type="none" w="med" len="med"/>
+                      <a:tailEnd type="none" w="med" len="med"/>
+                    </a:lnB>
+                  </a:tcPr>
+                </a:tc>
+                <a:tc>
+                  <a:txBody>
+                    <a:bodyPr/>
+                    <a:lstStyle/>
+                    <a:p>
+                      <a:pPr indent="0" marL="0">
+                        <a:buNone/>
+                      </a:pPr>
+                      <a:r>
+                        <a:rPr lang="en-US" sz="1600" dirty="0">
+                          <a:solidFill>
+                            <a:schemeClr val="tx1"/>
+                          </a:solidFill>
+                        </a:rPr>
+                        <a:t>Evaluasi dan penyesuaian</a:t>
+                      </a:r>
+                      <a:endParaRPr lang="en-US" sz="1600" dirty="0"/>
+                    </a:p>
+                  </a:txBody>
+                  <a:tcPr marL="101600" marR="101600" marT="63500" marB="63500" anchor="ctr">
+                    <a:lnL w="9525" cap="flat" cmpd="sng" algn="ctr">
+                      <a:solidFill>
+                        <a:srgbClr val="A6A6A6"/>
+                      </a:solidFill>
+                      <a:prstDash val="solid"/>
+                      <a:round/>
+                      <a:headEnd type="none" w="med" len="med"/>
+                      <a:tailEnd type="none" w="med" len="med"/>
+                    </a:lnL>
+                    <a:lnR w="9525" cap="flat" cmpd="sng" algn="ctr">
+                      <a:solidFill>
+                        <a:srgbClr val="A6A6A6"/>
+                      </a:solidFill>
+                      <a:prstDash val="solid"/>
+                      <a:round/>
+                      <a:headEnd type="none" w="med" len="med"/>
+                      <a:tailEnd type="none" w="med" len="med"/>
+                    </a:lnR>
+                    <a:lnT w="9525" cap="flat" cmpd="sng" algn="ctr">
+                      <a:solidFill>
+                        <a:srgbClr val="A6A6A6"/>
+                      </a:solidFill>
+                      <a:prstDash val="solid"/>
+                      <a:round/>
+                      <a:headEnd type="none" w="med" len="med"/>
+                      <a:tailEnd type="none" w="med" len="med"/>
+                    </a:lnT>
+                    <a:lnB w="9525" cap="flat" cmpd="sng" algn="ctr">
+                      <a:solidFill>
+                        <a:srgbClr val="A6A6A6"/>
+                      </a:solidFill>
+                      <a:prstDash val="solid"/>
+                      <a:round/>
+                      <a:headEnd type="none" w="med" len="med"/>
+                      <a:tailEnd type="none" w="med" len="med"/>
+                    </a:lnB>
+                  </a:tcPr>
+                </a:tc>
+                <a:tc>
+                  <a:txBody>
+                    <a:bodyPr/>
+                    <a:lstStyle/>
+                    <a:p>
+                      <a:pPr indent="0" marL="0">
+                        <a:buNone/>
+                      </a:pPr>
+                      <a:r>
+                        <a:rPr lang="en-US" sz="1600" dirty="0">
+                          <a:solidFill>
+                            <a:schemeClr val="tx1"/>
+                          </a:solidFill>
+                        </a:rPr>
+                        <a:t>Pimpinan dan Fungsi Pensosbud</a:t>
+                      </a:r>
+                      <a:endParaRPr lang="en-US" sz="1600" dirty="0"/>
+                    </a:p>
+                  </a:txBody>
+                  <a:tcPr marL="101600" marR="101600" marT="63500" marB="63500" anchor="ctr">
+                    <a:lnL w="9525" cap="flat" cmpd="sng" algn="ctr">
+                      <a:solidFill>
+                        <a:srgbClr val="A6A6A6"/>
+                      </a:solidFill>
+                      <a:prstDash val="solid"/>
+                      <a:round/>
+                      <a:headEnd type="none" w="med" len="med"/>
+                      <a:tailEnd type="none" w="med" len="med"/>
+                    </a:lnL>
+                    <a:lnR w="9525" cap="flat" cmpd="sng" algn="ctr">
+                      <a:solidFill>
+                        <a:srgbClr val="A6A6A6"/>
+                      </a:solidFill>
+                      <a:prstDash val="solid"/>
+                      <a:round/>
+                      <a:headEnd type="none" w="med" len="med"/>
+                      <a:tailEnd type="none" w="med" len="med"/>
+                    </a:lnR>
+                    <a:lnT w="9525" cap="flat" cmpd="sng" algn="ctr">
+                      <a:solidFill>
+                        <a:srgbClr val="A6A6A6"/>
+                      </a:solidFill>
+                      <a:prstDash val="solid"/>
+                      <a:round/>
+                      <a:headEnd type="none" w="med" len="med"/>
+                      <a:tailEnd type="none" w="med" len="med"/>
+                    </a:lnT>
+                    <a:lnB w="9525" cap="flat" cmpd="sng" algn="ctr">
+                      <a:solidFill>
+                        <a:srgbClr val="A6A6A6"/>
+                      </a:solidFill>
+                      <a:prstDash val="solid"/>
+                      <a:round/>
+                      <a:headEnd type="none" w="med" len="med"/>
+                      <a:tailEnd type="none" w="med" len="med"/>
+                    </a:lnB>
+                  </a:tcPr>
+                </a:tc>
+              </a:tr>
+            </a:tbl>
+          </a:graphicData>
+        </a:graphic>
+      </p:graphicFrame>
+      <p:sp>
+        <p:nvSpPr>
+          <p:cNvPr id="25" name="Slide Number Placeholder 0"/>
+          <p:cNvSpPr>
+            <a:spLocks noGrp="1"/>
+          </p:cNvSpPr>
+          <p:nvPr>
+            <p:ph type="sldNum" sz="quarter" idx="4294967295"/>
+          </p:nvPr>
+        </p:nvSpPr>
+        <p:spPr>
+          <a:xfrm>
+            <a:off x="11064240" y="6309360"/>
+            <a:ext cx="548640" cy="320040"/>
+          </a:xfrm>
+          <a:prstGeom prst="rect">
+            <a:avLst/>
+          </a:prstGeom>
+          <a:extLst>
+            <a:ext uri="{C572A759-6A51-4108-AA02-DFA0A04FC94B}">
+              <ma14:wrappingTextBoxFlag xmlns:ma14="http://schemas.microsoft.com/office/mac/drawingml/2011/main" val="0"/>
+            </a:ext>
+          </a:extLst>
+        </p:spPr>
+        <p:txBody>
+          <a:bodyPr lIns="0" tIns="0" rIns="0" bIns="0"/>
+          <a:lstStyle>
+            <a:lvl1pPr>
+              <a:defRPr sz="1100">
+                <a:solidFill>
+                  <a:srgbClr val="595959"/>
+                </a:solidFill>
+              </a:defRPr>
+            </a:lvl1pPr>
+          </a:lstStyle>
+          <a:p>
+            <a:pPr algn="r"/>
+            <a:fld id="{F7021451-1387-4CA6-816F-3879F97B5CBC}" type="slidenum">
+              <a:rPr b="0" lang="en-US"/>
+              <a:t>10</a:t>
+            </a:fld>
+            <a:endParaRPr lang="en-US"/>
+          </a:p>
+        </p:txBody>
+      </p:sp>
+    </p:spTree>
+  </p:cSld>
+  <p:clrMapOvr>
+    <a:masterClrMapping/>
+  </p:clrMapOvr>
+</p:sld>
+</file>
+
+<file path=ppt/slides/slide11.xml><?xml version="1.0" encoding="utf-8"?>
+<p:sld xmlns:a="http://schemas.openxmlformats.org/drawingml/2006/main" xmlns:r="http://schemas.openxmlformats.org/officeDocument/2006/relationships" xmlns:p="http://schemas.openxmlformats.org/presentationml/2006/main">
+  <p:cSld name="Slide 11">
+    <p:spTree>
+      <p:nvGrpSpPr>
+        <p:cNvPr id="1" name=""/>
+        <p:cNvGrpSpPr/>
+        <p:nvPr/>
+      </p:nvGrpSpPr>
+      <p:grpSpPr>
+        <a:xfrm>
+          <a:off x="0" y="0"/>
+          <a:ext cx="0" cy="0"/>
+          <a:chOff x="0" y="0"/>
+          <a:chExt cx="0" cy="0"/>
+        </a:xfrm>
+      </p:grpSpPr>
+      <p:sp>
+        <p:nvSpPr>
+          <p:cNvPr id="2" name="Text 0"/>
+          <p:cNvSpPr/>
+          <p:nvPr>
+            <p:ph idx="100" type="title" hasCustomPrompt="1"/>
+          </p:nvPr>
+        </p:nvSpPr>
+        <p:spPr>
+          <a:xfrm>
+            <a:off x="548640" y="320040"/>
+            <a:ext cx="11064240" cy="1005840"/>
+          </a:xfrm>
+          <a:prstGeom prst="rect">
+            <a:avLst/>
+          </a:prstGeom>
+          <a:noFill/>
+          <a:ln/>
+        </p:spPr>
+        <p:txBody>
+          <a:bodyPr wrap="square" lIns="0" tIns="0" rIns="0" bIns="0" rtlCol="0" anchor="ctr"/>
+          <a:lstStyle/>
+          <a:p>
+            <a:pPr algn="l" indent="0" marL="0">
+              <a:buNone/>
+            </a:pPr>
+            <a:r>
+              <a:rPr lang="en-US" sz="2800" b="1" dirty="0">
+                <a:solidFill>
+                  <a:schemeClr val="tx2"/>
+                </a:solidFill>
+              </a:rPr>
               <a:t>Hal yang dimohonkan arahan pimpinan</a:t>
             </a:r>
             <a:endParaRPr lang="en-US" sz="2800" dirty="0"/>
@@ -2718,7 +4011,7 @@
             <a:pPr algn="r"/>
             <a:fld id="{F7021451-1387-4CA6-816F-3879F97B5CBC}" type="slidenum">
               <a:rPr b="0" lang="en-US"/>
-              <a:t>10</a:t>
+              <a:t>11</a:t>
             </a:fld>
             <a:endParaRPr lang="en-US"/>
           </a:p>
@@ -2732,9 +4025,9 @@
 </p:sld>
 </file>
 
-<file path=ppt/slides/slide11.xml><?xml version="1.0" encoding="utf-8"?>
+<file path=ppt/slides/slide12.xml><?xml version="1.0" encoding="utf-8"?>
 <p:sld xmlns:a="http://schemas.openxmlformats.org/drawingml/2006/main" xmlns:r="http://schemas.openxmlformats.org/officeDocument/2006/relationships" xmlns:p="http://schemas.openxmlformats.org/presentationml/2006/main">
-  <p:cSld name="Slide 11">
+  <p:cSld name="Slide 12">
     <p:spTree>
       <p:nvGrpSpPr>
         <p:cNvPr id="1" name=""/>
@@ -2956,7 +4249,7 @@
             <a:pPr algn="r"/>
             <a:fld id="{F7021451-1387-4CA6-816F-3879F97B5CBC}" type="slidenum">
               <a:rPr b="0" lang="en-US"/>
-              <a:t>11</a:t>
+              <a:t>12</a:t>
             </a:fld>
             <a:endParaRPr lang="en-US"/>
           </a:p>
@@ -7679,942 +8972,22 @@
                   <a:schemeClr val="tx2"/>
                 </a:solidFill>
               </a:rPr>
-              <a:t>Ukuran keberhasilan: bukan hanya jumlah suka</a:t>
+              <a:t>Contoh unggahan KBRI untuk setiap kategori</a:t>
             </a:r>
             <a:endParaRPr lang="en-US" sz="2800" dirty="0"/>
           </a:p>
         </p:txBody>
       </p:sp>
-      <p:graphicFrame>
-        <p:nvGraphicFramePr>
-          <p:cNvPr id="9" name="Table 0"/>
-          <p:cNvGraphicFramePr>
-            <a:graphicFrameLocks noGrp="1"/>
-          </p:cNvGraphicFramePr>
-          <p:nvPr>
-            <p:extLst>
-              <p:ext uri="{D42A27DB-BD31-4B8C-83A1-F6EECF244321}">
-                <p14:modId xmlns:p14="http://schemas.microsoft.com/office/powerpoint/2010/main" val="1579011935"/>
-              </p:ext>
-            </p:extLst>
-          </p:nvPr>
-        </p:nvGraphicFramePr>
-        <p:xfrm>
-          <a:off x="548640" y="1554480"/>
-          <a:ext cx="11064240" cy="914400"/>
-        </p:xfrm>
-        <a:graphic>
-          <a:graphicData uri="http://schemas.openxmlformats.org/drawingml/2006/table">
-            <a:tbl>
-              <a:tblPr/>
-              <a:tblGrid>
-                <a:gridCol w="2560320"/>
-                <a:gridCol w="6766560"/>
-                <a:gridCol w="1737360"/>
-              </a:tblGrid>
-              <a:tr h="685800">
-                <a:tc>
-                  <a:txBody>
-                    <a:bodyPr/>
-                    <a:lstStyle/>
-                    <a:p>
-                      <a:pPr indent="0" marL="0">
-                        <a:buNone/>
-                      </a:pPr>
-                      <a:r>
-                        <a:rPr lang="en-US" sz="1600" b="1" dirty="0">
-                          <a:solidFill>
-                            <a:schemeClr val="tx1"/>
-                          </a:solidFill>
-                        </a:rPr>
-                        <a:t>Indikator</a:t>
-                      </a:r>
-                      <a:endParaRPr lang="en-US" sz="1600" dirty="0"/>
-                    </a:p>
-                  </a:txBody>
-                  <a:tcPr marL="101600" marR="101600" marT="63500" marB="63500" anchor="ctr">
-                    <a:lnL w="9525" cap="flat" cmpd="sng" algn="ctr">
-                      <a:solidFill>
-                        <a:srgbClr val="A6A6A6"/>
-                      </a:solidFill>
-                      <a:prstDash val="solid"/>
-                      <a:round/>
-                      <a:headEnd type="none" w="med" len="med"/>
-                      <a:tailEnd type="none" w="med" len="med"/>
-                    </a:lnL>
-                    <a:lnR w="9525" cap="flat" cmpd="sng" algn="ctr">
-                      <a:solidFill>
-                        <a:srgbClr val="A6A6A6"/>
-                      </a:solidFill>
-                      <a:prstDash val="solid"/>
-                      <a:round/>
-                      <a:headEnd type="none" w="med" len="med"/>
-                      <a:tailEnd type="none" w="med" len="med"/>
-                    </a:lnR>
-                    <a:lnT w="9525" cap="flat" cmpd="sng" algn="ctr">
-                      <a:solidFill>
-                        <a:srgbClr val="A6A6A6"/>
-                      </a:solidFill>
-                      <a:prstDash val="solid"/>
-                      <a:round/>
-                      <a:headEnd type="none" w="med" len="med"/>
-                      <a:tailEnd type="none" w="med" len="med"/>
-                    </a:lnT>
-                    <a:lnB w="9525" cap="flat" cmpd="sng" algn="ctr">
-                      <a:solidFill>
-                        <a:srgbClr val="A6A6A6"/>
-                      </a:solidFill>
-                      <a:prstDash val="solid"/>
-                      <a:round/>
-                      <a:headEnd type="none" w="med" len="med"/>
-                      <a:tailEnd type="none" w="med" len="med"/>
-                    </a:lnB>
-                    <a:solidFill>
-                      <a:srgbClr val="D9D9D9"/>
-                    </a:solidFill>
-                  </a:tcPr>
-                </a:tc>
-                <a:tc>
-                  <a:txBody>
-                    <a:bodyPr/>
-                    <a:lstStyle/>
-                    <a:p>
-                      <a:pPr indent="0" marL="0">
-                        <a:buNone/>
-                      </a:pPr>
-                      <a:r>
-                        <a:rPr lang="en-US" sz="1600" b="1" dirty="0">
-                          <a:solidFill>
-                            <a:schemeClr val="tx1"/>
-                          </a:solidFill>
-                        </a:rPr>
-                        <a:t>Yang diukur</a:t>
-                      </a:r>
-                      <a:endParaRPr lang="en-US" sz="1600" dirty="0"/>
-                    </a:p>
-                  </a:txBody>
-                  <a:tcPr marL="101600" marR="101600" marT="63500" marB="63500" anchor="ctr">
-                    <a:lnL w="9525" cap="flat" cmpd="sng" algn="ctr">
-                      <a:solidFill>
-                        <a:srgbClr val="A6A6A6"/>
-                      </a:solidFill>
-                      <a:prstDash val="solid"/>
-                      <a:round/>
-                      <a:headEnd type="none" w="med" len="med"/>
-                      <a:tailEnd type="none" w="med" len="med"/>
-                    </a:lnL>
-                    <a:lnR w="9525" cap="flat" cmpd="sng" algn="ctr">
-                      <a:solidFill>
-                        <a:srgbClr val="A6A6A6"/>
-                      </a:solidFill>
-                      <a:prstDash val="solid"/>
-                      <a:round/>
-                      <a:headEnd type="none" w="med" len="med"/>
-                      <a:tailEnd type="none" w="med" len="med"/>
-                    </a:lnR>
-                    <a:lnT w="9525" cap="flat" cmpd="sng" algn="ctr">
-                      <a:solidFill>
-                        <a:srgbClr val="A6A6A6"/>
-                      </a:solidFill>
-                      <a:prstDash val="solid"/>
-                      <a:round/>
-                      <a:headEnd type="none" w="med" len="med"/>
-                      <a:tailEnd type="none" w="med" len="med"/>
-                    </a:lnT>
-                    <a:lnB w="9525" cap="flat" cmpd="sng" algn="ctr">
-                      <a:solidFill>
-                        <a:srgbClr val="A6A6A6"/>
-                      </a:solidFill>
-                      <a:prstDash val="solid"/>
-                      <a:round/>
-                      <a:headEnd type="none" w="med" len="med"/>
-                      <a:tailEnd type="none" w="med" len="med"/>
-                    </a:lnB>
-                    <a:solidFill>
-                      <a:srgbClr val="D9D9D9"/>
-                    </a:solidFill>
-                  </a:tcPr>
-                </a:tc>
-                <a:tc>
-                  <a:txBody>
-                    <a:bodyPr/>
-                    <a:lstStyle/>
-                    <a:p>
-                      <a:pPr indent="0" marL="0">
-                        <a:buNone/>
-                      </a:pPr>
-                      <a:r>
-                        <a:rPr lang="en-US" sz="1600" b="1" dirty="0">
-                          <a:solidFill>
-                            <a:schemeClr val="tx1"/>
-                          </a:solidFill>
-                        </a:rPr>
-                        <a:t>Frekuensi</a:t>
-                      </a:r>
-                      <a:endParaRPr lang="en-US" sz="1600" dirty="0"/>
-                    </a:p>
-                  </a:txBody>
-                  <a:tcPr marL="101600" marR="101600" marT="63500" marB="63500" anchor="ctr">
-                    <a:lnL w="9525" cap="flat" cmpd="sng" algn="ctr">
-                      <a:solidFill>
-                        <a:srgbClr val="A6A6A6"/>
-                      </a:solidFill>
-                      <a:prstDash val="solid"/>
-                      <a:round/>
-                      <a:headEnd type="none" w="med" len="med"/>
-                      <a:tailEnd type="none" w="med" len="med"/>
-                    </a:lnL>
-                    <a:lnR w="9525" cap="flat" cmpd="sng" algn="ctr">
-                      <a:solidFill>
-                        <a:srgbClr val="A6A6A6"/>
-                      </a:solidFill>
-                      <a:prstDash val="solid"/>
-                      <a:round/>
-                      <a:headEnd type="none" w="med" len="med"/>
-                      <a:tailEnd type="none" w="med" len="med"/>
-                    </a:lnR>
-                    <a:lnT w="9525" cap="flat" cmpd="sng" algn="ctr">
-                      <a:solidFill>
-                        <a:srgbClr val="A6A6A6"/>
-                      </a:solidFill>
-                      <a:prstDash val="solid"/>
-                      <a:round/>
-                      <a:headEnd type="none" w="med" len="med"/>
-                      <a:tailEnd type="none" w="med" len="med"/>
-                    </a:lnT>
-                    <a:lnB w="9525" cap="flat" cmpd="sng" algn="ctr">
-                      <a:solidFill>
-                        <a:srgbClr val="A6A6A6"/>
-                      </a:solidFill>
-                      <a:prstDash val="solid"/>
-                      <a:round/>
-                      <a:headEnd type="none" w="med" len="med"/>
-                      <a:tailEnd type="none" w="med" len="med"/>
-                    </a:lnB>
-                    <a:solidFill>
-                      <a:srgbClr val="D9D9D9"/>
-                    </a:solidFill>
-                  </a:tcPr>
-                </a:tc>
-              </a:tr>
-              <a:tr h="685800">
-                <a:tc>
-                  <a:txBody>
-                    <a:bodyPr/>
-                    <a:lstStyle/>
-                    <a:p>
-                      <a:pPr indent="0" marL="0">
-                        <a:buNone/>
-                      </a:pPr>
-                      <a:r>
-                        <a:rPr lang="en-US" sz="1600" b="1" dirty="0">
-                          <a:solidFill>
-                            <a:schemeClr val="tx1"/>
-                          </a:solidFill>
-                        </a:rPr>
-                        <a:t>Proporsi konten</a:t>
-                      </a:r>
-                      <a:endParaRPr lang="en-US" sz="1600" dirty="0"/>
-                    </a:p>
-                  </a:txBody>
-                  <a:tcPr marL="101600" marR="101600" marT="63500" marB="63500" anchor="ctr">
-                    <a:lnL w="9525" cap="flat" cmpd="sng" algn="ctr">
-                      <a:solidFill>
-                        <a:srgbClr val="A6A6A6"/>
-                      </a:solidFill>
-                      <a:prstDash val="solid"/>
-                      <a:round/>
-                      <a:headEnd type="none" w="med" len="med"/>
-                      <a:tailEnd type="none" w="med" len="med"/>
-                    </a:lnL>
-                    <a:lnR w="9525" cap="flat" cmpd="sng" algn="ctr">
-                      <a:solidFill>
-                        <a:srgbClr val="A6A6A6"/>
-                      </a:solidFill>
-                      <a:prstDash val="solid"/>
-                      <a:round/>
-                      <a:headEnd type="none" w="med" len="med"/>
-                      <a:tailEnd type="none" w="med" len="med"/>
-                    </a:lnR>
-                    <a:lnT w="9525" cap="flat" cmpd="sng" algn="ctr">
-                      <a:solidFill>
-                        <a:srgbClr val="A6A6A6"/>
-                      </a:solidFill>
-                      <a:prstDash val="solid"/>
-                      <a:round/>
-                      <a:headEnd type="none" w="med" len="med"/>
-                      <a:tailEnd type="none" w="med" len="med"/>
-                    </a:lnT>
-                    <a:lnB w="9525" cap="flat" cmpd="sng" algn="ctr">
-                      <a:solidFill>
-                        <a:srgbClr val="A6A6A6"/>
-                      </a:solidFill>
-                      <a:prstDash val="solid"/>
-                      <a:round/>
-                      <a:headEnd type="none" w="med" len="med"/>
-                      <a:tailEnd type="none" w="med" len="med"/>
-                    </a:lnB>
-                  </a:tcPr>
-                </a:tc>
-                <a:tc>
-                  <a:txBody>
-                    <a:bodyPr/>
-                    <a:lstStyle/>
-                    <a:p>
-                      <a:pPr indent="0" marL="0">
-                        <a:buNone/>
-                      </a:pPr>
-                      <a:r>
-                        <a:rPr lang="en-US" sz="1600" dirty="0">
-                          <a:solidFill>
-                            <a:schemeClr val="tx1"/>
-                          </a:solidFill>
-                        </a:rPr>
-                        <a:t>Persentase unggahan per kategori dibanding target</a:t>
-                      </a:r>
-                      <a:endParaRPr lang="en-US" sz="1600" dirty="0"/>
-                    </a:p>
-                  </a:txBody>
-                  <a:tcPr marL="101600" marR="101600" marT="63500" marB="63500" anchor="ctr">
-                    <a:lnL w="9525" cap="flat" cmpd="sng" algn="ctr">
-                      <a:solidFill>
-                        <a:srgbClr val="A6A6A6"/>
-                      </a:solidFill>
-                      <a:prstDash val="solid"/>
-                      <a:round/>
-                      <a:headEnd type="none" w="med" len="med"/>
-                      <a:tailEnd type="none" w="med" len="med"/>
-                    </a:lnL>
-                    <a:lnR w="9525" cap="flat" cmpd="sng" algn="ctr">
-                      <a:solidFill>
-                        <a:srgbClr val="A6A6A6"/>
-                      </a:solidFill>
-                      <a:prstDash val="solid"/>
-                      <a:round/>
-                      <a:headEnd type="none" w="med" len="med"/>
-                      <a:tailEnd type="none" w="med" len="med"/>
-                    </a:lnR>
-                    <a:lnT w="9525" cap="flat" cmpd="sng" algn="ctr">
-                      <a:solidFill>
-                        <a:srgbClr val="A6A6A6"/>
-                      </a:solidFill>
-                      <a:prstDash val="solid"/>
-                      <a:round/>
-                      <a:headEnd type="none" w="med" len="med"/>
-                      <a:tailEnd type="none" w="med" len="med"/>
-                    </a:lnT>
-                    <a:lnB w="9525" cap="flat" cmpd="sng" algn="ctr">
-                      <a:solidFill>
-                        <a:srgbClr val="A6A6A6"/>
-                      </a:solidFill>
-                      <a:prstDash val="solid"/>
-                      <a:round/>
-                      <a:headEnd type="none" w="med" len="med"/>
-                      <a:tailEnd type="none" w="med" len="med"/>
-                    </a:lnB>
-                  </a:tcPr>
-                </a:tc>
-                <a:tc>
-                  <a:txBody>
-                    <a:bodyPr/>
-                    <a:lstStyle/>
-                    <a:p>
-                      <a:pPr indent="0" marL="0">
-                        <a:buNone/>
-                      </a:pPr>
-                      <a:r>
-                        <a:rPr lang="en-US" sz="1600" dirty="0">
-                          <a:solidFill>
-                            <a:schemeClr val="tx1"/>
-                          </a:solidFill>
-                        </a:rPr>
-                        <a:t>Bulanan</a:t>
-                      </a:r>
-                      <a:endParaRPr lang="en-US" sz="1600" dirty="0"/>
-                    </a:p>
-                  </a:txBody>
-                  <a:tcPr marL="101600" marR="101600" marT="63500" marB="63500" anchor="ctr">
-                    <a:lnL w="9525" cap="flat" cmpd="sng" algn="ctr">
-                      <a:solidFill>
-                        <a:srgbClr val="A6A6A6"/>
-                      </a:solidFill>
-                      <a:prstDash val="solid"/>
-                      <a:round/>
-                      <a:headEnd type="none" w="med" len="med"/>
-                      <a:tailEnd type="none" w="med" len="med"/>
-                    </a:lnL>
-                    <a:lnR w="9525" cap="flat" cmpd="sng" algn="ctr">
-                      <a:solidFill>
-                        <a:srgbClr val="A6A6A6"/>
-                      </a:solidFill>
-                      <a:prstDash val="solid"/>
-                      <a:round/>
-                      <a:headEnd type="none" w="med" len="med"/>
-                      <a:tailEnd type="none" w="med" len="med"/>
-                    </a:lnR>
-                    <a:lnT w="9525" cap="flat" cmpd="sng" algn="ctr">
-                      <a:solidFill>
-                        <a:srgbClr val="A6A6A6"/>
-                      </a:solidFill>
-                      <a:prstDash val="solid"/>
-                      <a:round/>
-                      <a:headEnd type="none" w="med" len="med"/>
-                      <a:tailEnd type="none" w="med" len="med"/>
-                    </a:lnT>
-                    <a:lnB w="9525" cap="flat" cmpd="sng" algn="ctr">
-                      <a:solidFill>
-                        <a:srgbClr val="A6A6A6"/>
-                      </a:solidFill>
-                      <a:prstDash val="solid"/>
-                      <a:round/>
-                      <a:headEnd type="none" w="med" len="med"/>
-                      <a:tailEnd type="none" w="med" len="med"/>
-                    </a:lnB>
-                  </a:tcPr>
-                </a:tc>
-              </a:tr>
-              <a:tr h="685800">
-                <a:tc>
-                  <a:txBody>
-                    <a:bodyPr/>
-                    <a:lstStyle/>
-                    <a:p>
-                      <a:pPr indent="0" marL="0">
-                        <a:buNone/>
-                      </a:pPr>
-                      <a:r>
-                        <a:rPr lang="en-US" sz="1600" b="1" dirty="0">
-                          <a:solidFill>
-                            <a:schemeClr val="tx1"/>
-                          </a:solidFill>
-                        </a:rPr>
-                        <a:t>Jangkauan</a:t>
-                      </a:r>
-                      <a:endParaRPr lang="en-US" sz="1600" dirty="0"/>
-                    </a:p>
-                  </a:txBody>
-                  <a:tcPr marL="101600" marR="101600" marT="63500" marB="63500" anchor="ctr">
-                    <a:lnL w="9525" cap="flat" cmpd="sng" algn="ctr">
-                      <a:solidFill>
-                        <a:srgbClr val="A6A6A6"/>
-                      </a:solidFill>
-                      <a:prstDash val="solid"/>
-                      <a:round/>
-                      <a:headEnd type="none" w="med" len="med"/>
-                      <a:tailEnd type="none" w="med" len="med"/>
-                    </a:lnL>
-                    <a:lnR w="9525" cap="flat" cmpd="sng" algn="ctr">
-                      <a:solidFill>
-                        <a:srgbClr val="A6A6A6"/>
-                      </a:solidFill>
-                      <a:prstDash val="solid"/>
-                      <a:round/>
-                      <a:headEnd type="none" w="med" len="med"/>
-                      <a:tailEnd type="none" w="med" len="med"/>
-                    </a:lnR>
-                    <a:lnT w="9525" cap="flat" cmpd="sng" algn="ctr">
-                      <a:solidFill>
-                        <a:srgbClr val="A6A6A6"/>
-                      </a:solidFill>
-                      <a:prstDash val="solid"/>
-                      <a:round/>
-                      <a:headEnd type="none" w="med" len="med"/>
-                      <a:tailEnd type="none" w="med" len="med"/>
-                    </a:lnT>
-                    <a:lnB w="9525" cap="flat" cmpd="sng" algn="ctr">
-                      <a:solidFill>
-                        <a:srgbClr val="A6A6A6"/>
-                      </a:solidFill>
-                      <a:prstDash val="solid"/>
-                      <a:round/>
-                      <a:headEnd type="none" w="med" len="med"/>
-                      <a:tailEnd type="none" w="med" len="med"/>
-                    </a:lnB>
-                  </a:tcPr>
-                </a:tc>
-                <a:tc>
-                  <a:txBody>
-                    <a:bodyPr/>
-                    <a:lstStyle/>
-                    <a:p>
-                      <a:pPr indent="0" marL="0">
-                        <a:buNone/>
-                      </a:pPr>
-                      <a:r>
-                        <a:rPr lang="en-US" sz="1600" dirty="0">
-                          <a:solidFill>
-                            <a:schemeClr val="tx1"/>
-                          </a:solidFill>
-                        </a:rPr>
-                        <a:t>Persentase pengikut dan jangkauan dari Austria (Instagram Insights)</a:t>
-                      </a:r>
-                      <a:endParaRPr lang="en-US" sz="1600" dirty="0"/>
-                    </a:p>
-                  </a:txBody>
-                  <a:tcPr marL="101600" marR="101600" marT="63500" marB="63500" anchor="ctr">
-                    <a:lnL w="9525" cap="flat" cmpd="sng" algn="ctr">
-                      <a:solidFill>
-                        <a:srgbClr val="A6A6A6"/>
-                      </a:solidFill>
-                      <a:prstDash val="solid"/>
-                      <a:round/>
-                      <a:headEnd type="none" w="med" len="med"/>
-                      <a:tailEnd type="none" w="med" len="med"/>
-                    </a:lnL>
-                    <a:lnR w="9525" cap="flat" cmpd="sng" algn="ctr">
-                      <a:solidFill>
-                        <a:srgbClr val="A6A6A6"/>
-                      </a:solidFill>
-                      <a:prstDash val="solid"/>
-                      <a:round/>
-                      <a:headEnd type="none" w="med" len="med"/>
-                      <a:tailEnd type="none" w="med" len="med"/>
-                    </a:lnR>
-                    <a:lnT w="9525" cap="flat" cmpd="sng" algn="ctr">
-                      <a:solidFill>
-                        <a:srgbClr val="A6A6A6"/>
-                      </a:solidFill>
-                      <a:prstDash val="solid"/>
-                      <a:round/>
-                      <a:headEnd type="none" w="med" len="med"/>
-                      <a:tailEnd type="none" w="med" len="med"/>
-                    </a:lnT>
-                    <a:lnB w="9525" cap="flat" cmpd="sng" algn="ctr">
-                      <a:solidFill>
-                        <a:srgbClr val="A6A6A6"/>
-                      </a:solidFill>
-                      <a:prstDash val="solid"/>
-                      <a:round/>
-                      <a:headEnd type="none" w="med" len="med"/>
-                      <a:tailEnd type="none" w="med" len="med"/>
-                    </a:lnB>
-                  </a:tcPr>
-                </a:tc>
-                <a:tc>
-                  <a:txBody>
-                    <a:bodyPr/>
-                    <a:lstStyle/>
-                    <a:p>
-                      <a:pPr indent="0" marL="0">
-                        <a:buNone/>
-                      </a:pPr>
-                      <a:r>
-                        <a:rPr lang="en-US" sz="1600" dirty="0">
-                          <a:solidFill>
-                            <a:schemeClr val="tx1"/>
-                          </a:solidFill>
-                        </a:rPr>
-                        <a:t>Bulanan</a:t>
-                      </a:r>
-                      <a:endParaRPr lang="en-US" sz="1600" dirty="0"/>
-                    </a:p>
-                  </a:txBody>
-                  <a:tcPr marL="101600" marR="101600" marT="63500" marB="63500" anchor="ctr">
-                    <a:lnL w="9525" cap="flat" cmpd="sng" algn="ctr">
-                      <a:solidFill>
-                        <a:srgbClr val="A6A6A6"/>
-                      </a:solidFill>
-                      <a:prstDash val="solid"/>
-                      <a:round/>
-                      <a:headEnd type="none" w="med" len="med"/>
-                      <a:tailEnd type="none" w="med" len="med"/>
-                    </a:lnL>
-                    <a:lnR w="9525" cap="flat" cmpd="sng" algn="ctr">
-                      <a:solidFill>
-                        <a:srgbClr val="A6A6A6"/>
-                      </a:solidFill>
-                      <a:prstDash val="solid"/>
-                      <a:round/>
-                      <a:headEnd type="none" w="med" len="med"/>
-                      <a:tailEnd type="none" w="med" len="med"/>
-                    </a:lnR>
-                    <a:lnT w="9525" cap="flat" cmpd="sng" algn="ctr">
-                      <a:solidFill>
-                        <a:srgbClr val="A6A6A6"/>
-                      </a:solidFill>
-                      <a:prstDash val="solid"/>
-                      <a:round/>
-                      <a:headEnd type="none" w="med" len="med"/>
-                      <a:tailEnd type="none" w="med" len="med"/>
-                    </a:lnT>
-                    <a:lnB w="9525" cap="flat" cmpd="sng" algn="ctr">
-                      <a:solidFill>
-                        <a:srgbClr val="A6A6A6"/>
-                      </a:solidFill>
-                      <a:prstDash val="solid"/>
-                      <a:round/>
-                      <a:headEnd type="none" w="med" len="med"/>
-                      <a:tailEnd type="none" w="med" len="med"/>
-                    </a:lnB>
-                  </a:tcPr>
-                </a:tc>
-              </a:tr>
-              <a:tr h="685800">
-                <a:tc>
-                  <a:txBody>
-                    <a:bodyPr/>
-                    <a:lstStyle/>
-                    <a:p>
-                      <a:pPr indent="0" marL="0">
-                        <a:buNone/>
-                      </a:pPr>
-                      <a:r>
-                        <a:rPr lang="en-US" sz="1600" b="1" dirty="0">
-                          <a:solidFill>
-                            <a:schemeClr val="tx1"/>
-                          </a:solidFill>
-                        </a:rPr>
-                        <a:t>Persepsi</a:t>
-                      </a:r>
-                      <a:endParaRPr lang="en-US" sz="1600" dirty="0"/>
-                    </a:p>
-                  </a:txBody>
-                  <a:tcPr marL="101600" marR="101600" marT="63500" marB="63500" anchor="ctr">
-                    <a:lnL w="9525" cap="flat" cmpd="sng" algn="ctr">
-                      <a:solidFill>
-                        <a:srgbClr val="A6A6A6"/>
-                      </a:solidFill>
-                      <a:prstDash val="solid"/>
-                      <a:round/>
-                      <a:headEnd type="none" w="med" len="med"/>
-                      <a:tailEnd type="none" w="med" len="med"/>
-                    </a:lnL>
-                    <a:lnR w="9525" cap="flat" cmpd="sng" algn="ctr">
-                      <a:solidFill>
-                        <a:srgbClr val="A6A6A6"/>
-                      </a:solidFill>
-                      <a:prstDash val="solid"/>
-                      <a:round/>
-                      <a:headEnd type="none" w="med" len="med"/>
-                      <a:tailEnd type="none" w="med" len="med"/>
-                    </a:lnR>
-                    <a:lnT w="9525" cap="flat" cmpd="sng" algn="ctr">
-                      <a:solidFill>
-                        <a:srgbClr val="A6A6A6"/>
-                      </a:solidFill>
-                      <a:prstDash val="solid"/>
-                      <a:round/>
-                      <a:headEnd type="none" w="med" len="med"/>
-                      <a:tailEnd type="none" w="med" len="med"/>
-                    </a:lnT>
-                    <a:lnB w="9525" cap="flat" cmpd="sng" algn="ctr">
-                      <a:solidFill>
-                        <a:srgbClr val="A6A6A6"/>
-                      </a:solidFill>
-                      <a:prstDash val="solid"/>
-                      <a:round/>
-                      <a:headEnd type="none" w="med" len="med"/>
-                      <a:tailEnd type="none" w="med" len="med"/>
-                    </a:lnB>
-                  </a:tcPr>
-                </a:tc>
-                <a:tc>
-                  <a:txBody>
-                    <a:bodyPr/>
-                    <a:lstStyle/>
-                    <a:p>
-                      <a:pPr indent="0" marL="0">
-                        <a:buNone/>
-                      </a:pPr>
-                      <a:r>
-                        <a:rPr lang="en-US" sz="1600" dirty="0">
-                          <a:solidFill>
-                            <a:schemeClr val="tx1"/>
-                          </a:solidFill>
-                        </a:rPr>
-                        <a:t>Pertanyaan ICI kepada responden Austria di luar acara KBRI</a:t>
-                      </a:r>
-                      <a:endParaRPr lang="en-US" sz="1600" dirty="0"/>
-                    </a:p>
-                  </a:txBody>
-                  <a:tcPr marL="101600" marR="101600" marT="63500" marB="63500" anchor="ctr">
-                    <a:lnL w="9525" cap="flat" cmpd="sng" algn="ctr">
-                      <a:solidFill>
-                        <a:srgbClr val="A6A6A6"/>
-                      </a:solidFill>
-                      <a:prstDash val="solid"/>
-                      <a:round/>
-                      <a:headEnd type="none" w="med" len="med"/>
-                      <a:tailEnd type="none" w="med" len="med"/>
-                    </a:lnL>
-                    <a:lnR w="9525" cap="flat" cmpd="sng" algn="ctr">
-                      <a:solidFill>
-                        <a:srgbClr val="A6A6A6"/>
-                      </a:solidFill>
-                      <a:prstDash val="solid"/>
-                      <a:round/>
-                      <a:headEnd type="none" w="med" len="med"/>
-                      <a:tailEnd type="none" w="med" len="med"/>
-                    </a:lnR>
-                    <a:lnT w="9525" cap="flat" cmpd="sng" algn="ctr">
-                      <a:solidFill>
-                        <a:srgbClr val="A6A6A6"/>
-                      </a:solidFill>
-                      <a:prstDash val="solid"/>
-                      <a:round/>
-                      <a:headEnd type="none" w="med" len="med"/>
-                      <a:tailEnd type="none" w="med" len="med"/>
-                    </a:lnT>
-                    <a:lnB w="9525" cap="flat" cmpd="sng" algn="ctr">
-                      <a:solidFill>
-                        <a:srgbClr val="A6A6A6"/>
-                      </a:solidFill>
-                      <a:prstDash val="solid"/>
-                      <a:round/>
-                      <a:headEnd type="none" w="med" len="med"/>
-                      <a:tailEnd type="none" w="med" len="med"/>
-                    </a:lnB>
-                  </a:tcPr>
-                </a:tc>
-                <a:tc>
-                  <a:txBody>
-                    <a:bodyPr/>
-                    <a:lstStyle/>
-                    <a:p>
-                      <a:pPr indent="0" marL="0">
-                        <a:buNone/>
-                      </a:pPr>
-                      <a:r>
-                        <a:rPr lang="en-US" sz="1600" dirty="0">
-                          <a:solidFill>
-                            <a:schemeClr val="tx1"/>
-                          </a:solidFill>
-                        </a:rPr>
-                        <a:t>Tahunan</a:t>
-                      </a:r>
-                      <a:endParaRPr lang="en-US" sz="1600" dirty="0"/>
-                    </a:p>
-                  </a:txBody>
-                  <a:tcPr marL="101600" marR="101600" marT="63500" marB="63500" anchor="ctr">
-                    <a:lnL w="9525" cap="flat" cmpd="sng" algn="ctr">
-                      <a:solidFill>
-                        <a:srgbClr val="A6A6A6"/>
-                      </a:solidFill>
-                      <a:prstDash val="solid"/>
-                      <a:round/>
-                      <a:headEnd type="none" w="med" len="med"/>
-                      <a:tailEnd type="none" w="med" len="med"/>
-                    </a:lnL>
-                    <a:lnR w="9525" cap="flat" cmpd="sng" algn="ctr">
-                      <a:solidFill>
-                        <a:srgbClr val="A6A6A6"/>
-                      </a:solidFill>
-                      <a:prstDash val="solid"/>
-                      <a:round/>
-                      <a:headEnd type="none" w="med" len="med"/>
-                      <a:tailEnd type="none" w="med" len="med"/>
-                    </a:lnR>
-                    <a:lnT w="9525" cap="flat" cmpd="sng" algn="ctr">
-                      <a:solidFill>
-                        <a:srgbClr val="A6A6A6"/>
-                      </a:solidFill>
-                      <a:prstDash val="solid"/>
-                      <a:round/>
-                      <a:headEnd type="none" w="med" len="med"/>
-                      <a:tailEnd type="none" w="med" len="med"/>
-                    </a:lnT>
-                    <a:lnB w="9525" cap="flat" cmpd="sng" algn="ctr">
-                      <a:solidFill>
-                        <a:srgbClr val="A6A6A6"/>
-                      </a:solidFill>
-                      <a:prstDash val="solid"/>
-                      <a:round/>
-                      <a:headEnd type="none" w="med" len="med"/>
-                      <a:tailEnd type="none" w="med" len="med"/>
-                    </a:lnB>
-                  </a:tcPr>
-                </a:tc>
-              </a:tr>
-              <a:tr h="685800">
-                <a:tc>
-                  <a:txBody>
-                    <a:bodyPr/>
-                    <a:lstStyle/>
-                    <a:p>
-                      <a:pPr indent="0" marL="0">
-                        <a:buNone/>
-                      </a:pPr>
-                      <a:r>
-                        <a:rPr lang="en-US" sz="1600" b="1" dirty="0">
-                          <a:solidFill>
-                            <a:schemeClr val="tx1"/>
-                          </a:solidFill>
-                        </a:rPr>
-                        <a:t>Respons</a:t>
-                      </a:r>
-                      <a:endParaRPr lang="en-US" sz="1600" dirty="0"/>
-                    </a:p>
-                  </a:txBody>
-                  <a:tcPr marL="101600" marR="101600" marT="63500" marB="63500" anchor="ctr">
-                    <a:lnL w="9525" cap="flat" cmpd="sng" algn="ctr">
-                      <a:solidFill>
-                        <a:srgbClr val="A6A6A6"/>
-                      </a:solidFill>
-                      <a:prstDash val="solid"/>
-                      <a:round/>
-                      <a:headEnd type="none" w="med" len="med"/>
-                      <a:tailEnd type="none" w="med" len="med"/>
-                    </a:lnL>
-                    <a:lnR w="9525" cap="flat" cmpd="sng" algn="ctr">
-                      <a:solidFill>
-                        <a:srgbClr val="A6A6A6"/>
-                      </a:solidFill>
-                      <a:prstDash val="solid"/>
-                      <a:round/>
-                      <a:headEnd type="none" w="med" len="med"/>
-                      <a:tailEnd type="none" w="med" len="med"/>
-                    </a:lnR>
-                    <a:lnT w="9525" cap="flat" cmpd="sng" algn="ctr">
-                      <a:solidFill>
-                        <a:srgbClr val="A6A6A6"/>
-                      </a:solidFill>
-                      <a:prstDash val="solid"/>
-                      <a:round/>
-                      <a:headEnd type="none" w="med" len="med"/>
-                      <a:tailEnd type="none" w="med" len="med"/>
-                    </a:lnT>
-                    <a:lnB w="9525" cap="flat" cmpd="sng" algn="ctr">
-                      <a:solidFill>
-                        <a:srgbClr val="A6A6A6"/>
-                      </a:solidFill>
-                      <a:prstDash val="solid"/>
-                      <a:round/>
-                      <a:headEnd type="none" w="med" len="med"/>
-                      <a:tailEnd type="none" w="med" len="med"/>
-                    </a:lnB>
-                  </a:tcPr>
-                </a:tc>
-                <a:tc>
-                  <a:txBody>
-                    <a:bodyPr/>
-                    <a:lstStyle/>
-                    <a:p>
-                      <a:pPr indent="0" marL="0">
-                        <a:buNone/>
-                      </a:pPr>
-                      <a:r>
-                        <a:rPr lang="en-US" sz="1600" dirty="0">
-                          <a:solidFill>
-                            <a:schemeClr val="tx1"/>
-                          </a:solidFill>
-                        </a:rPr>
-                        <a:t>Suka, komentar, simpan; sebagai pelengkap, bukan ukuran utama</a:t>
-                      </a:r>
-                      <a:endParaRPr lang="en-US" sz="1600" dirty="0"/>
-                    </a:p>
-                  </a:txBody>
-                  <a:tcPr marL="101600" marR="101600" marT="63500" marB="63500" anchor="ctr">
-                    <a:lnL w="9525" cap="flat" cmpd="sng" algn="ctr">
-                      <a:solidFill>
-                        <a:srgbClr val="A6A6A6"/>
-                      </a:solidFill>
-                      <a:prstDash val="solid"/>
-                      <a:round/>
-                      <a:headEnd type="none" w="med" len="med"/>
-                      <a:tailEnd type="none" w="med" len="med"/>
-                    </a:lnL>
-                    <a:lnR w="9525" cap="flat" cmpd="sng" algn="ctr">
-                      <a:solidFill>
-                        <a:srgbClr val="A6A6A6"/>
-                      </a:solidFill>
-                      <a:prstDash val="solid"/>
-                      <a:round/>
-                      <a:headEnd type="none" w="med" len="med"/>
-                      <a:tailEnd type="none" w="med" len="med"/>
-                    </a:lnR>
-                    <a:lnT w="9525" cap="flat" cmpd="sng" algn="ctr">
-                      <a:solidFill>
-                        <a:srgbClr val="A6A6A6"/>
-                      </a:solidFill>
-                      <a:prstDash val="solid"/>
-                      <a:round/>
-                      <a:headEnd type="none" w="med" len="med"/>
-                      <a:tailEnd type="none" w="med" len="med"/>
-                    </a:lnT>
-                    <a:lnB w="9525" cap="flat" cmpd="sng" algn="ctr">
-                      <a:solidFill>
-                        <a:srgbClr val="A6A6A6"/>
-                      </a:solidFill>
-                      <a:prstDash val="solid"/>
-                      <a:round/>
-                      <a:headEnd type="none" w="med" len="med"/>
-                      <a:tailEnd type="none" w="med" len="med"/>
-                    </a:lnB>
-                  </a:tcPr>
-                </a:tc>
-                <a:tc>
-                  <a:txBody>
-                    <a:bodyPr/>
-                    <a:lstStyle/>
-                    <a:p>
-                      <a:pPr indent="0" marL="0">
-                        <a:buNone/>
-                      </a:pPr>
-                      <a:r>
-                        <a:rPr lang="en-US" sz="1600" dirty="0">
-                          <a:solidFill>
-                            <a:schemeClr val="tx1"/>
-                          </a:solidFill>
-                        </a:rPr>
-                        <a:t>Bulanan</a:t>
-                      </a:r>
-                      <a:endParaRPr lang="en-US" sz="1600" dirty="0"/>
-                    </a:p>
-                  </a:txBody>
-                  <a:tcPr marL="101600" marR="101600" marT="63500" marB="63500" anchor="ctr">
-                    <a:lnL w="9525" cap="flat" cmpd="sng" algn="ctr">
-                      <a:solidFill>
-                        <a:srgbClr val="A6A6A6"/>
-                      </a:solidFill>
-                      <a:prstDash val="solid"/>
-                      <a:round/>
-                      <a:headEnd type="none" w="med" len="med"/>
-                      <a:tailEnd type="none" w="med" len="med"/>
-                    </a:lnL>
-                    <a:lnR w="9525" cap="flat" cmpd="sng" algn="ctr">
-                      <a:solidFill>
-                        <a:srgbClr val="A6A6A6"/>
-                      </a:solidFill>
-                      <a:prstDash val="solid"/>
-                      <a:round/>
-                      <a:headEnd type="none" w="med" len="med"/>
-                      <a:tailEnd type="none" w="med" len="med"/>
-                    </a:lnR>
-                    <a:lnT w="9525" cap="flat" cmpd="sng" algn="ctr">
-                      <a:solidFill>
-                        <a:srgbClr val="A6A6A6"/>
-                      </a:solidFill>
-                      <a:prstDash val="solid"/>
-                      <a:round/>
-                      <a:headEnd type="none" w="med" len="med"/>
-                      <a:tailEnd type="none" w="med" len="med"/>
-                    </a:lnT>
-                    <a:lnB w="9525" cap="flat" cmpd="sng" algn="ctr">
-                      <a:solidFill>
-                        <a:srgbClr val="A6A6A6"/>
-                      </a:solidFill>
-                      <a:prstDash val="solid"/>
-                      <a:round/>
-                      <a:headEnd type="none" w="med" len="med"/>
-                      <a:tailEnd type="none" w="med" len="med"/>
-                    </a:lnB>
-                  </a:tcPr>
-                </a:tc>
-              </a:tr>
-            </a:tbl>
-          </a:graphicData>
-        </a:graphic>
-      </p:graphicFrame>
       <p:sp>
         <p:nvSpPr>
-          <p:cNvPr id="4" name="Text 1"/>
+          <p:cNvPr id="3" name="Text 1"/>
           <p:cNvSpPr txBox="1"/>
           <p:nvPr/>
         </p:nvSpPr>
         <p:spPr>
           <a:xfrm>
-            <a:off x="548640" y="5257800"/>
-            <a:ext cx="11064240" cy="822960"/>
+            <a:off x="548640" y="1371600"/>
+            <a:ext cx="3566160" cy="365760"/>
           </a:xfrm>
           <a:prstGeom prst="rect">
             <a:avLst/>
@@ -8630,14 +9003,482 @@
               <a:buNone/>
             </a:pPr>
             <a:r>
-              <a:rPr lang="en-US" sz="1600" dirty="0">
+              <a:rPr lang="en-US" sz="1800" b="1" dirty="0">
+                <a:solidFill>
+                  <a:schemeClr val="tx1"/>
+                </a:solidFill>
+              </a:rPr>
+              <a:t>A. Budaya &amp; Pariwisata</a:t>
+            </a:r>
+            <a:endParaRPr lang="en-US" sz="1800" dirty="0"/>
+          </a:p>
+        </p:txBody>
+      </p:sp>
+      <p:pic>
+        <p:nvPicPr>
+          <p:cNvPr id="4" name="Image 0" descr="Jatiluwih, Bali: warisan budaya dunia (2024)">    </p:cNvPr>
+          <p:cNvPicPr>
+            <a:picLocks noChangeAspect="1"/>
+          </p:cNvPicPr>
+          <p:nvPr/>
+        </p:nvPicPr>
+        <p:blipFill>
+          <a:blip r:embed="rId1"/>
+          <a:stretch>
+            <a:fillRect/>
+          </a:stretch>
+        </p:blipFill>
+        <p:spPr>
+          <a:xfrm>
+            <a:off x="548640" y="1828800"/>
+            <a:ext cx="1828800" cy="1828800"/>
+          </a:xfrm>
+          <a:prstGeom prst="rect">
+            <a:avLst/>
+          </a:prstGeom>
+        </p:spPr>
+      </p:pic>
+      <p:sp>
+        <p:nvSpPr>
+          <p:cNvPr id="5" name="Text 2"/>
+          <p:cNvSpPr txBox="1"/>
+          <p:nvPr/>
+        </p:nvSpPr>
+        <p:spPr>
+          <a:xfrm>
+            <a:off x="2514600" y="1828800"/>
+            <a:ext cx="1600200" cy="1828800"/>
+          </a:xfrm>
+          <a:prstGeom prst="rect">
+            <a:avLst/>
+          </a:prstGeom>
+          <a:noFill/>
+          <a:ln/>
+        </p:spPr>
+        <p:txBody>
+          <a:bodyPr wrap="square" lIns="0" tIns="0" rIns="0" bIns="0" rtlCol="0" anchor="ctr"/>
+          <a:lstStyle/>
+          <a:p>
+            <a:pPr indent="0" marL="0">
+              <a:buNone/>
+            </a:pPr>
+            <a:r>
+              <a:rPr lang="en-US" sz="1400" dirty="0">
+                <a:solidFill>
+                  <a:schemeClr val="tx1"/>
+                </a:solidFill>
+              </a:rPr>
+              <a:t>Jatiluwih, Bali: warisan budaya dunia (2024)</a:t>
+            </a:r>
+            <a:endParaRPr lang="en-US" sz="1400" dirty="0"/>
+          </a:p>
+        </p:txBody>
+      </p:sp>
+      <p:pic>
+        <p:nvPicPr>
+          <p:cNvPr id="6" name="Image 1" descr="Kelas Bahasa Indonesia di Universität Wien, dalam bahasa Jerman (2025)">    </p:cNvPr>
+          <p:cNvPicPr>
+            <a:picLocks noChangeAspect="1"/>
+          </p:cNvPicPr>
+          <p:nvPr/>
+        </p:nvPicPr>
+        <p:blipFill>
+          <a:blip r:embed="rId2"/>
+          <a:stretch>
+            <a:fillRect/>
+          </a:stretch>
+        </p:blipFill>
+        <p:spPr>
+          <a:xfrm>
+            <a:off x="548640" y="3840480"/>
+            <a:ext cx="1828800" cy="1828800"/>
+          </a:xfrm>
+          <a:prstGeom prst="rect">
+            <a:avLst/>
+          </a:prstGeom>
+        </p:spPr>
+      </p:pic>
+      <p:sp>
+        <p:nvSpPr>
+          <p:cNvPr id="7" name="Text 3"/>
+          <p:cNvSpPr txBox="1"/>
+          <p:nvPr/>
+        </p:nvSpPr>
+        <p:spPr>
+          <a:xfrm>
+            <a:off x="2514600" y="3840480"/>
+            <a:ext cx="1600200" cy="1828800"/>
+          </a:xfrm>
+          <a:prstGeom prst="rect">
+            <a:avLst/>
+          </a:prstGeom>
+          <a:noFill/>
+          <a:ln/>
+        </p:spPr>
+        <p:txBody>
+          <a:bodyPr wrap="square" lIns="0" tIns="0" rIns="0" bIns="0" rtlCol="0" anchor="ctr"/>
+          <a:lstStyle/>
+          <a:p>
+            <a:pPr indent="0" marL="0">
+              <a:buNone/>
+            </a:pPr>
+            <a:r>
+              <a:rPr lang="en-US" sz="1400" dirty="0">
+                <a:solidFill>
+                  <a:schemeClr val="tx1"/>
+                </a:solidFill>
+              </a:rPr>
+              <a:t>Kelas Bahasa Indonesia di Universität Wien, dalam bahasa Jerman (2025)</a:t>
+            </a:r>
+            <a:endParaRPr lang="en-US" sz="1400" dirty="0"/>
+          </a:p>
+        </p:txBody>
+      </p:sp>
+      <p:sp>
+        <p:nvSpPr>
+          <p:cNvPr id="8" name="Text 4"/>
+          <p:cNvSpPr txBox="1"/>
+          <p:nvPr/>
+        </p:nvSpPr>
+        <p:spPr>
+          <a:xfrm>
+            <a:off x="4297680" y="1371600"/>
+            <a:ext cx="3566160" cy="365760"/>
+          </a:xfrm>
+          <a:prstGeom prst="rect">
+            <a:avLst/>
+          </a:prstGeom>
+          <a:noFill/>
+          <a:ln/>
+        </p:spPr>
+        <p:txBody>
+          <a:bodyPr wrap="square" lIns="0" tIns="0" rIns="0" bIns="0" rtlCol="0" anchor="ctr"/>
+          <a:lstStyle/>
+          <a:p>
+            <a:pPr indent="0" marL="0">
+              <a:buNone/>
+            </a:pPr>
+            <a:r>
+              <a:rPr lang="en-US" sz="1800" b="1" dirty="0">
+                <a:solidFill>
+                  <a:schemeClr val="tx1"/>
+                </a:solidFill>
+              </a:rPr>
+              <a:t>B. Ekonomi &amp; Bisnis</a:t>
+            </a:r>
+            <a:endParaRPr lang="en-US" sz="1800" dirty="0"/>
+          </a:p>
+        </p:txBody>
+      </p:sp>
+      <p:pic>
+        <p:nvPicPr>
+          <p:cNvPr id="9" name="Image 2" descr="Indonesia–Europe Business Forum (2023)">    </p:cNvPr>
+          <p:cNvPicPr>
+            <a:picLocks noChangeAspect="1"/>
+          </p:cNvPicPr>
+          <p:nvPr/>
+        </p:nvPicPr>
+        <p:blipFill>
+          <a:blip r:embed="rId3"/>
+          <a:stretch>
+            <a:fillRect/>
+          </a:stretch>
+        </p:blipFill>
+        <p:spPr>
+          <a:xfrm>
+            <a:off x="4297680" y="1828800"/>
+            <a:ext cx="1828800" cy="1828800"/>
+          </a:xfrm>
+          <a:prstGeom prst="rect">
+            <a:avLst/>
+          </a:prstGeom>
+        </p:spPr>
+      </p:pic>
+      <p:sp>
+        <p:nvSpPr>
+          <p:cNvPr id="10" name="Text 5"/>
+          <p:cNvSpPr txBox="1"/>
+          <p:nvPr/>
+        </p:nvSpPr>
+        <p:spPr>
+          <a:xfrm>
+            <a:off x="6263640" y="1828800"/>
+            <a:ext cx="1600200" cy="1828800"/>
+          </a:xfrm>
+          <a:prstGeom prst="rect">
+            <a:avLst/>
+          </a:prstGeom>
+          <a:noFill/>
+          <a:ln/>
+        </p:spPr>
+        <p:txBody>
+          <a:bodyPr wrap="square" lIns="0" tIns="0" rIns="0" bIns="0" rtlCol="0" anchor="ctr"/>
+          <a:lstStyle/>
+          <a:p>
+            <a:pPr indent="0" marL="0">
+              <a:buNone/>
+            </a:pPr>
+            <a:r>
+              <a:rPr lang="en-US" sz="1400" dirty="0">
+                <a:solidFill>
+                  <a:schemeClr val="tx1"/>
+                </a:solidFill>
+              </a:rPr>
+              <a:t>Indonesia–Europe Business Forum (2023)</a:t>
+            </a:r>
+            <a:endParaRPr lang="en-US" sz="1400" dirty="0"/>
+          </a:p>
+        </p:txBody>
+      </p:sp>
+      <p:pic>
+        <p:nvPicPr>
+          <p:cNvPr id="11" name="Image 3" descr="Indonesia Coffee &amp; Culture (2026)">    </p:cNvPr>
+          <p:cNvPicPr>
+            <a:picLocks noChangeAspect="1"/>
+          </p:cNvPicPr>
+          <p:nvPr/>
+        </p:nvPicPr>
+        <p:blipFill>
+          <a:blip r:embed="rId4"/>
+          <a:stretch>
+            <a:fillRect/>
+          </a:stretch>
+        </p:blipFill>
+        <p:spPr>
+          <a:xfrm>
+            <a:off x="4297680" y="3840480"/>
+            <a:ext cx="1828800" cy="1828800"/>
+          </a:xfrm>
+          <a:prstGeom prst="rect">
+            <a:avLst/>
+          </a:prstGeom>
+        </p:spPr>
+      </p:pic>
+      <p:sp>
+        <p:nvSpPr>
+          <p:cNvPr id="12" name="Text 6"/>
+          <p:cNvSpPr txBox="1"/>
+          <p:nvPr/>
+        </p:nvSpPr>
+        <p:spPr>
+          <a:xfrm>
+            <a:off x="6263640" y="3840480"/>
+            <a:ext cx="1600200" cy="1828800"/>
+          </a:xfrm>
+          <a:prstGeom prst="rect">
+            <a:avLst/>
+          </a:prstGeom>
+          <a:noFill/>
+          <a:ln/>
+        </p:spPr>
+        <p:txBody>
+          <a:bodyPr wrap="square" lIns="0" tIns="0" rIns="0" bIns="0" rtlCol="0" anchor="ctr"/>
+          <a:lstStyle/>
+          <a:p>
+            <a:pPr indent="0" marL="0">
+              <a:buNone/>
+            </a:pPr>
+            <a:r>
+              <a:rPr lang="en-US" sz="1400" dirty="0">
+                <a:solidFill>
+                  <a:schemeClr val="tx1"/>
+                </a:solidFill>
+              </a:rPr>
+              <a:t>Indonesia Coffee &amp; Culture (2026)</a:t>
+            </a:r>
+            <a:endParaRPr lang="en-US" sz="1400" dirty="0"/>
+          </a:p>
+        </p:txBody>
+      </p:sp>
+      <p:sp>
+        <p:nvSpPr>
+          <p:cNvPr id="13" name="Text 7"/>
+          <p:cNvSpPr txBox="1"/>
+          <p:nvPr/>
+        </p:nvSpPr>
+        <p:spPr>
+          <a:xfrm>
+            <a:off x="8046720" y="1371600"/>
+            <a:ext cx="3566160" cy="365760"/>
+          </a:xfrm>
+          <a:prstGeom prst="rect">
+            <a:avLst/>
+          </a:prstGeom>
+          <a:noFill/>
+          <a:ln/>
+        </p:spPr>
+        <p:txBody>
+          <a:bodyPr wrap="square" lIns="0" tIns="0" rIns="0" bIns="0" rtlCol="0" anchor="ctr"/>
+          <a:lstStyle/>
+          <a:p>
+            <a:pPr indent="0" marL="0">
+              <a:buNone/>
+            </a:pPr>
+            <a:r>
+              <a:rPr lang="en-US" sz="1800" b="1" dirty="0">
+                <a:solidFill>
+                  <a:schemeClr val="tx1"/>
+                </a:solidFill>
+              </a:rPr>
+              <a:t>C. Tata Kelola &amp; Keamanan</a:t>
+            </a:r>
+            <a:endParaRPr lang="en-US" sz="1800" dirty="0"/>
+          </a:p>
+        </p:txBody>
+      </p:sp>
+      <p:pic>
+        <p:nvPicPr>
+          <p:cNvPr id="14" name="Image 4" descr="Daftar negara penerima Visa on Arrival (2023)">    </p:cNvPr>
+          <p:cNvPicPr>
+            <a:picLocks noChangeAspect="1"/>
+          </p:cNvPicPr>
+          <p:nvPr/>
+        </p:nvPicPr>
+        <p:blipFill>
+          <a:blip r:embed="rId5"/>
+          <a:stretch>
+            <a:fillRect/>
+          </a:stretch>
+        </p:blipFill>
+        <p:spPr>
+          <a:xfrm>
+            <a:off x="8046720" y="1828800"/>
+            <a:ext cx="1828800" cy="1828800"/>
+          </a:xfrm>
+          <a:prstGeom prst="rect">
+            <a:avLst/>
+          </a:prstGeom>
+        </p:spPr>
+      </p:pic>
+      <p:sp>
+        <p:nvSpPr>
+          <p:cNvPr id="15" name="Text 8"/>
+          <p:cNvSpPr txBox="1"/>
+          <p:nvPr/>
+        </p:nvSpPr>
+        <p:spPr>
+          <a:xfrm>
+            <a:off x="10012680" y="1828800"/>
+            <a:ext cx="1600200" cy="1828800"/>
+          </a:xfrm>
+          <a:prstGeom prst="rect">
+            <a:avLst/>
+          </a:prstGeom>
+          <a:noFill/>
+          <a:ln/>
+        </p:spPr>
+        <p:txBody>
+          <a:bodyPr wrap="square" lIns="0" tIns="0" rIns="0" bIns="0" rtlCol="0" anchor="ctr"/>
+          <a:lstStyle/>
+          <a:p>
+            <a:pPr indent="0" marL="0">
+              <a:buNone/>
+            </a:pPr>
+            <a:r>
+              <a:rPr lang="en-US" sz="1400" dirty="0">
+                <a:solidFill>
+                  <a:schemeClr val="tx1"/>
+                </a:solidFill>
+              </a:rPr>
+              <a:t>Daftar negara penerima Visa on Arrival (2023)</a:t>
+            </a:r>
+            <a:endParaRPr lang="en-US" sz="1400" dirty="0"/>
+          </a:p>
+        </p:txBody>
+      </p:sp>
+      <p:pic>
+        <p:nvPicPr>
+          <p:cNvPr id="16" name="Image 5" descr="Golden Visa: izin tinggal hingga 10 tahun (2024)">    </p:cNvPr>
+          <p:cNvPicPr>
+            <a:picLocks noChangeAspect="1"/>
+          </p:cNvPicPr>
+          <p:nvPr/>
+        </p:nvPicPr>
+        <p:blipFill>
+          <a:blip r:embed="rId6"/>
+          <a:stretch>
+            <a:fillRect/>
+          </a:stretch>
+        </p:blipFill>
+        <p:spPr>
+          <a:xfrm>
+            <a:off x="8046720" y="3840480"/>
+            <a:ext cx="1828800" cy="1828800"/>
+          </a:xfrm>
+          <a:prstGeom prst="rect">
+            <a:avLst/>
+          </a:prstGeom>
+        </p:spPr>
+      </p:pic>
+      <p:sp>
+        <p:nvSpPr>
+          <p:cNvPr id="17" name="Text 9"/>
+          <p:cNvSpPr txBox="1"/>
+          <p:nvPr/>
+        </p:nvSpPr>
+        <p:spPr>
+          <a:xfrm>
+            <a:off x="10012680" y="3840480"/>
+            <a:ext cx="1600200" cy="1828800"/>
+          </a:xfrm>
+          <a:prstGeom prst="rect">
+            <a:avLst/>
+          </a:prstGeom>
+          <a:noFill/>
+          <a:ln/>
+        </p:spPr>
+        <p:txBody>
+          <a:bodyPr wrap="square" lIns="0" tIns="0" rIns="0" bIns="0" rtlCol="0" anchor="ctr"/>
+          <a:lstStyle/>
+          <a:p>
+            <a:pPr indent="0" marL="0">
+              <a:buNone/>
+            </a:pPr>
+            <a:r>
+              <a:rPr lang="en-US" sz="1400" dirty="0">
+                <a:solidFill>
+                  <a:schemeClr val="tx1"/>
+                </a:solidFill>
+              </a:rPr>
+              <a:t>Golden Visa: izin tinggal hingga 10 tahun (2024)</a:t>
+            </a:r>
+            <a:endParaRPr lang="en-US" sz="1400" dirty="0"/>
+          </a:p>
+        </p:txBody>
+      </p:sp>
+      <p:sp>
+        <p:nvSpPr>
+          <p:cNvPr id="18" name="Text 10"/>
+          <p:cNvSpPr txBox="1"/>
+          <p:nvPr/>
+        </p:nvSpPr>
+        <p:spPr>
+          <a:xfrm>
+            <a:off x="548640" y="5852160"/>
+            <a:ext cx="11064240" cy="320040"/>
+          </a:xfrm>
+          <a:prstGeom prst="rect">
+            <a:avLst/>
+          </a:prstGeom>
+          <a:noFill/>
+          <a:ln/>
+        </p:spPr>
+        <p:txBody>
+          <a:bodyPr wrap="square" lIns="0" tIns="0" rIns="0" bIns="0" rtlCol="0" anchor="ctr"/>
+          <a:lstStyle/>
+          <a:p>
+            <a:pPr indent="0" marL="0">
+              <a:buNone/>
+            </a:pPr>
+            <a:r>
+              <a:rPr lang="en-US" sz="1200" dirty="0">
                 <a:solidFill>
                   <a:schemeClr val="accent5"/>
                 </a:solidFill>
               </a:rPr>
-              <a:t>Indikator ini menunjukkan apakah pembagian konten berjalan sesuai rencana dan apakah publik Austria terjangkau. Indikator ini tidak dapat membuktikan bahwa Instagram mengubah persepsi.</a:t>
+              <a:t>Sumber: akun Instagram @inainvienna.</a:t>
             </a:r>
-            <a:endParaRPr lang="en-US" sz="1600" dirty="0"/>
+            <a:endParaRPr lang="en-US" sz="1200" dirty="0"/>
           </a:p>
         </p:txBody>
       </p:sp>
@@ -8743,7 +9584,7 @@
                   <a:schemeClr val="tx2"/>
                 </a:solidFill>
               </a:rPr>
-              <a:t>Langkah tiga bulan pertama</a:t>
+              <a:t>Ukuran keberhasilan: bukan hanya jumlah suka</a:t>
             </a:r>
             <a:endParaRPr lang="en-US" sz="2800" dirty="0"/>
           </a:p>
@@ -8772,11 +9613,11 @@
             <a:tbl>
               <a:tblPr/>
               <a:tblGrid>
-                <a:gridCol w="1645920"/>
-                <a:gridCol w="6035040"/>
-                <a:gridCol w="3383280"/>
+                <a:gridCol w="2560320"/>
+                <a:gridCol w="6766560"/>
+                <a:gridCol w="1737360"/>
               </a:tblGrid>
-              <a:tr h="658368">
+              <a:tr h="685800">
                 <a:tc>
                   <a:txBody>
                     <a:bodyPr/>
@@ -8791,7 +9632,7 @@
                             <a:schemeClr val="tx1"/>
                           </a:solidFill>
                         </a:rPr>
-                        <a:t>Waktu</a:t>
+                        <a:t>Indikator</a:t>
                       </a:r>
                       <a:endParaRPr lang="en-US" sz="1600" dirty="0"/>
                     </a:p>
@@ -8852,7 +9693,7 @@
                             <a:schemeClr val="tx1"/>
                           </a:solidFill>
                         </a:rPr>
-                        <a:t>Kegiatan</a:t>
+                        <a:t>Yang diukur</a:t>
                       </a:r>
                       <a:endParaRPr lang="en-US" sz="1600" dirty="0"/>
                     </a:p>
@@ -8913,7 +9754,7 @@
                             <a:schemeClr val="tx1"/>
                           </a:solidFill>
                         </a:rPr>
-                        <a:t>Pelaksana</a:t>
+                        <a:t>Frekuensi</a:t>
                       </a:r>
                       <a:endParaRPr lang="en-US" sz="1600" dirty="0"/>
                     </a:p>
@@ -8961,7 +9802,7 @@
                   </a:tcPr>
                 </a:tc>
               </a:tr>
-              <a:tr h="658368">
+              <a:tr h="685800">
                 <a:tc>
                   <a:txBody>
                     <a:bodyPr/>
@@ -8971,12 +9812,12 @@
                         <a:buNone/>
                       </a:pPr>
                       <a:r>
-                        <a:rPr lang="en-US" sz="1600" dirty="0">
+                        <a:rPr lang="en-US" sz="1600" b="1" dirty="0">
                           <a:solidFill>
                             <a:schemeClr val="tx1"/>
                           </a:solidFill>
                         </a:rPr>
-                        <a:t>Bulan 1</a:t>
+                        <a:t>Proporsi konten</a:t>
                       </a:r>
                       <a:endParaRPr lang="en-US" sz="1600" dirty="0"/>
                     </a:p>
@@ -9034,7 +9875,7 @@
                             <a:schemeClr val="tx1"/>
                           </a:solidFill>
                         </a:rPr>
-                        <a:t>Pemeriksaan manual 50 unggahan untuk menguji ketepatan klasifikasi</a:t>
+                        <a:t>Persentase unggahan per kategori dibanding target</a:t>
                       </a:r>
                       <a:endParaRPr lang="en-US" sz="1600" dirty="0"/>
                     </a:p>
@@ -9092,7 +9933,7 @@
                             <a:schemeClr val="tx1"/>
                           </a:solidFill>
                         </a:rPr>
-                        <a:t>Pengelola akun, dibantu magang</a:t>
+                        <a:t>Bulanan</a:t>
                       </a:r>
                       <a:endParaRPr lang="en-US" sz="1600" dirty="0"/>
                     </a:p>
@@ -9137,7 +9978,7 @@
                   </a:tcPr>
                 </a:tc>
               </a:tr>
-              <a:tr h="658368">
+              <a:tr h="685800">
                 <a:tc>
                   <a:txBody>
                     <a:bodyPr/>
@@ -9147,12 +9988,12 @@
                         <a:buNone/>
                       </a:pPr>
                       <a:r>
-                        <a:rPr lang="en-US" sz="1600" dirty="0">
+                        <a:rPr lang="en-US" sz="1600" b="1" dirty="0">
                           <a:solidFill>
                             <a:schemeClr val="tx1"/>
                           </a:solidFill>
                         </a:rPr>
-                        <a:t>Bulan 1</a:t>
+                        <a:t>Jangkauan</a:t>
                       </a:r>
                       <a:endParaRPr lang="en-US" sz="1600" dirty="0"/>
                     </a:p>
@@ -9210,7 +10051,7 @@
                             <a:schemeClr val="tx1"/>
                           </a:solidFill>
                         </a:rPr>
-                        <a:t>Pengambilan data asal pengikut dan jangkauan (Instagram Insights)</a:t>
+                        <a:t>Persentase pengikut dan jangkauan dari Austria (Instagram Insights)</a:t>
                       </a:r>
                       <a:endParaRPr lang="en-US" sz="1600" dirty="0"/>
                     </a:p>
@@ -9268,7 +10109,7 @@
                             <a:schemeClr val="tx1"/>
                           </a:solidFill>
                         </a:rPr>
-                        <a:t>Pengelola akun</a:t>
+                        <a:t>Bulanan</a:t>
                       </a:r>
                       <a:endParaRPr lang="en-US" sz="1600" dirty="0"/>
                     </a:p>
@@ -9313,7 +10154,7 @@
                   </a:tcPr>
                 </a:tc>
               </a:tr>
-              <a:tr h="658368">
+              <a:tr h="685800">
                 <a:tc>
                   <a:txBody>
                     <a:bodyPr/>
@@ -9323,12 +10164,12 @@
                         <a:buNone/>
                       </a:pPr>
                       <a:r>
-                        <a:rPr lang="en-US" sz="1600" dirty="0">
+                        <a:rPr lang="en-US" sz="1600" b="1" dirty="0">
                           <a:solidFill>
                             <a:schemeClr val="tx1"/>
                           </a:solidFill>
                         </a:rPr>
-                        <a:t>Bulan 1</a:t>
+                        <a:t>Persepsi</a:t>
                       </a:r>
                       <a:endParaRPr lang="en-US" sz="1600" dirty="0"/>
                     </a:p>
@@ -9386,7 +10227,7 @@
                             <a:schemeClr val="tx1"/>
                           </a:solidFill>
                         </a:rPr>
-                        <a:t>Penetapan proporsi awal kategori A, B, C</a:t>
+                        <a:t>Pertanyaan ICI kepada responden Austria di luar acara KBRI</a:t>
                       </a:r>
                       <a:endParaRPr lang="en-US" sz="1600" dirty="0"/>
                     </a:p>
@@ -9444,7 +10285,7 @@
                             <a:schemeClr val="tx1"/>
                           </a:solidFill>
                         </a:rPr>
-                        <a:t>Pimpinan</a:t>
+                        <a:t>Tahunan</a:t>
                       </a:r>
                       <a:endParaRPr lang="en-US" sz="1600" dirty="0"/>
                     </a:p>
@@ -9489,7 +10330,7 @@
                   </a:tcPr>
                 </a:tc>
               </a:tr>
-              <a:tr h="658368">
+              <a:tr h="685800">
                 <a:tc>
                   <a:txBody>
                     <a:bodyPr/>
@@ -9499,12 +10340,12 @@
                         <a:buNone/>
                       </a:pPr>
                       <a:r>
-                        <a:rPr lang="en-US" sz="1600" dirty="0">
+                        <a:rPr lang="en-US" sz="1600" b="1" dirty="0">
                           <a:solidFill>
                             <a:schemeClr val="tx1"/>
                           </a:solidFill>
                         </a:rPr>
-                        <a:t>Bulan 2–3</a:t>
+                        <a:t>Respons</a:t>
                       </a:r>
                       <a:endParaRPr lang="en-US" sz="1600" dirty="0"/>
                     </a:p>
@@ -9562,7 +10403,7 @@
                             <a:schemeClr val="tx1"/>
                           </a:solidFill>
                         </a:rPr>
-                        <a:t>Uji coba: setiap unggahan diberi kategori sebelum terbit; laporan bulanan</a:t>
+                        <a:t>Suka, komentar, simpan; sebagai pelengkap, bukan ukuran utama</a:t>
                       </a:r>
                       <a:endParaRPr lang="en-US" sz="1600" dirty="0"/>
                     </a:p>
@@ -9620,183 +10461,7 @@
                             <a:schemeClr val="tx1"/>
                           </a:solidFill>
                         </a:rPr>
-                        <a:t>Pengelola akun, dibantu magang</a:t>
-                      </a:r>
-                      <a:endParaRPr lang="en-US" sz="1600" dirty="0"/>
-                    </a:p>
-                  </a:txBody>
-                  <a:tcPr marL="101600" marR="101600" marT="63500" marB="63500" anchor="ctr">
-                    <a:lnL w="9525" cap="flat" cmpd="sng" algn="ctr">
-                      <a:solidFill>
-                        <a:srgbClr val="A6A6A6"/>
-                      </a:solidFill>
-                      <a:prstDash val="solid"/>
-                      <a:round/>
-                      <a:headEnd type="none" w="med" len="med"/>
-                      <a:tailEnd type="none" w="med" len="med"/>
-                    </a:lnL>
-                    <a:lnR w="9525" cap="flat" cmpd="sng" algn="ctr">
-                      <a:solidFill>
-                        <a:srgbClr val="A6A6A6"/>
-                      </a:solidFill>
-                      <a:prstDash val="solid"/>
-                      <a:round/>
-                      <a:headEnd type="none" w="med" len="med"/>
-                      <a:tailEnd type="none" w="med" len="med"/>
-                    </a:lnR>
-                    <a:lnT w="9525" cap="flat" cmpd="sng" algn="ctr">
-                      <a:solidFill>
-                        <a:srgbClr val="A6A6A6"/>
-                      </a:solidFill>
-                      <a:prstDash val="solid"/>
-                      <a:round/>
-                      <a:headEnd type="none" w="med" len="med"/>
-                      <a:tailEnd type="none" w="med" len="med"/>
-                    </a:lnT>
-                    <a:lnB w="9525" cap="flat" cmpd="sng" algn="ctr">
-                      <a:solidFill>
-                        <a:srgbClr val="A6A6A6"/>
-                      </a:solidFill>
-                      <a:prstDash val="solid"/>
-                      <a:round/>
-                      <a:headEnd type="none" w="med" len="med"/>
-                      <a:tailEnd type="none" w="med" len="med"/>
-                    </a:lnB>
-                  </a:tcPr>
-                </a:tc>
-              </a:tr>
-              <a:tr h="658368">
-                <a:tc>
-                  <a:txBody>
-                    <a:bodyPr/>
-                    <a:lstStyle/>
-                    <a:p>
-                      <a:pPr indent="0" marL="0">
-                        <a:buNone/>
-                      </a:pPr>
-                      <a:r>
-                        <a:rPr lang="en-US" sz="1600" dirty="0">
-                          <a:solidFill>
-                            <a:schemeClr val="tx1"/>
-                          </a:solidFill>
-                        </a:rPr>
-                        <a:t>Bulan 3</a:t>
-                      </a:r>
-                      <a:endParaRPr lang="en-US" sz="1600" dirty="0"/>
-                    </a:p>
-                  </a:txBody>
-                  <a:tcPr marL="101600" marR="101600" marT="63500" marB="63500" anchor="ctr">
-                    <a:lnL w="9525" cap="flat" cmpd="sng" algn="ctr">
-                      <a:solidFill>
-                        <a:srgbClr val="A6A6A6"/>
-                      </a:solidFill>
-                      <a:prstDash val="solid"/>
-                      <a:round/>
-                      <a:headEnd type="none" w="med" len="med"/>
-                      <a:tailEnd type="none" w="med" len="med"/>
-                    </a:lnL>
-                    <a:lnR w="9525" cap="flat" cmpd="sng" algn="ctr">
-                      <a:solidFill>
-                        <a:srgbClr val="A6A6A6"/>
-                      </a:solidFill>
-                      <a:prstDash val="solid"/>
-                      <a:round/>
-                      <a:headEnd type="none" w="med" len="med"/>
-                      <a:tailEnd type="none" w="med" len="med"/>
-                    </a:lnR>
-                    <a:lnT w="9525" cap="flat" cmpd="sng" algn="ctr">
-                      <a:solidFill>
-                        <a:srgbClr val="A6A6A6"/>
-                      </a:solidFill>
-                      <a:prstDash val="solid"/>
-                      <a:round/>
-                      <a:headEnd type="none" w="med" len="med"/>
-                      <a:tailEnd type="none" w="med" len="med"/>
-                    </a:lnT>
-                    <a:lnB w="9525" cap="flat" cmpd="sng" algn="ctr">
-                      <a:solidFill>
-                        <a:srgbClr val="A6A6A6"/>
-                      </a:solidFill>
-                      <a:prstDash val="solid"/>
-                      <a:round/>
-                      <a:headEnd type="none" w="med" len="med"/>
-                      <a:tailEnd type="none" w="med" len="med"/>
-                    </a:lnB>
-                  </a:tcPr>
-                </a:tc>
-                <a:tc>
-                  <a:txBody>
-                    <a:bodyPr/>
-                    <a:lstStyle/>
-                    <a:p>
-                      <a:pPr indent="0" marL="0">
-                        <a:buNone/>
-                      </a:pPr>
-                      <a:r>
-                        <a:rPr lang="en-US" sz="1600" dirty="0">
-                          <a:solidFill>
-                            <a:schemeClr val="tx1"/>
-                          </a:solidFill>
-                        </a:rPr>
-                        <a:t>Evaluasi dan penyesuaian</a:t>
-                      </a:r>
-                      <a:endParaRPr lang="en-US" sz="1600" dirty="0"/>
-                    </a:p>
-                  </a:txBody>
-                  <a:tcPr marL="101600" marR="101600" marT="63500" marB="63500" anchor="ctr">
-                    <a:lnL w="9525" cap="flat" cmpd="sng" algn="ctr">
-                      <a:solidFill>
-                        <a:srgbClr val="A6A6A6"/>
-                      </a:solidFill>
-                      <a:prstDash val="solid"/>
-                      <a:round/>
-                      <a:headEnd type="none" w="med" len="med"/>
-                      <a:tailEnd type="none" w="med" len="med"/>
-                    </a:lnL>
-                    <a:lnR w="9525" cap="flat" cmpd="sng" algn="ctr">
-                      <a:solidFill>
-                        <a:srgbClr val="A6A6A6"/>
-                      </a:solidFill>
-                      <a:prstDash val="solid"/>
-                      <a:round/>
-                      <a:headEnd type="none" w="med" len="med"/>
-                      <a:tailEnd type="none" w="med" len="med"/>
-                    </a:lnR>
-                    <a:lnT w="9525" cap="flat" cmpd="sng" algn="ctr">
-                      <a:solidFill>
-                        <a:srgbClr val="A6A6A6"/>
-                      </a:solidFill>
-                      <a:prstDash val="solid"/>
-                      <a:round/>
-                      <a:headEnd type="none" w="med" len="med"/>
-                      <a:tailEnd type="none" w="med" len="med"/>
-                    </a:lnT>
-                    <a:lnB w="9525" cap="flat" cmpd="sng" algn="ctr">
-                      <a:solidFill>
-                        <a:srgbClr val="A6A6A6"/>
-                      </a:solidFill>
-                      <a:prstDash val="solid"/>
-                      <a:round/>
-                      <a:headEnd type="none" w="med" len="med"/>
-                      <a:tailEnd type="none" w="med" len="med"/>
-                    </a:lnB>
-                  </a:tcPr>
-                </a:tc>
-                <a:tc>
-                  <a:txBody>
-                    <a:bodyPr/>
-                    <a:lstStyle/>
-                    <a:p>
-                      <a:pPr indent="0" marL="0">
-                        <a:buNone/>
-                      </a:pPr>
-                      <a:r>
-                        <a:rPr lang="en-US" sz="1600" dirty="0">
-                          <a:solidFill>
-                            <a:schemeClr val="tx1"/>
-                          </a:solidFill>
-                        </a:rPr>
-                        <a:t>Pimpinan dan Fungsi Pensosbud</a:t>
+                        <a:t>Bulanan</a:t>
                       </a:r>
                       <a:endParaRPr lang="en-US" sz="1600" dirty="0"/>
                     </a:p>
@@ -9845,6 +10510,42 @@
           </a:graphicData>
         </a:graphic>
       </p:graphicFrame>
+      <p:sp>
+        <p:nvSpPr>
+          <p:cNvPr id="4" name="Text 1"/>
+          <p:cNvSpPr txBox="1"/>
+          <p:nvPr/>
+        </p:nvSpPr>
+        <p:spPr>
+          <a:xfrm>
+            <a:off x="548640" y="5257800"/>
+            <a:ext cx="11064240" cy="822960"/>
+          </a:xfrm>
+          <a:prstGeom prst="rect">
+            <a:avLst/>
+          </a:prstGeom>
+          <a:noFill/>
+          <a:ln/>
+        </p:spPr>
+        <p:txBody>
+          <a:bodyPr wrap="square" lIns="0" tIns="0" rIns="0" bIns="0" rtlCol="0" anchor="ctr"/>
+          <a:lstStyle/>
+          <a:p>
+            <a:pPr indent="0" marL="0">
+              <a:buNone/>
+            </a:pPr>
+            <a:r>
+              <a:rPr lang="en-US" sz="1600" dirty="0">
+                <a:solidFill>
+                  <a:schemeClr val="accent5"/>
+                </a:solidFill>
+              </a:rPr>
+              <a:t>Indikator ini menunjukkan apakah pembagian konten berjalan sesuai rencana dan apakah publik Austria terjangkau. Indikator ini tidak dapat membuktikan bahwa Instagram mengubah persepsi.</a:t>
+            </a:r>
+            <a:endParaRPr lang="en-US" sz="1600" dirty="0"/>
+          </a:p>
+        </p:txBody>
+      </p:sp>
       <p:sp>
         <p:nvSpPr>
           <p:cNvPr id="25" name="Slide Number Placeholder 0"/>

</xml_diff>